<commit_message>
update ppt, add pics
</commit_message>
<xml_diff>
--- a/project1/Proj1_Present_Energy_Ouspenskaia.pptx
+++ b/project1/Proj1_Present_Energy_Ouspenskaia.pptx
@@ -5,13 +5,22 @@
     <p:sldMasterId id="2147483762" r:id="rId1"/>
   </p:sldMasterIdLst>
   <p:notesMasterIdLst>
-    <p:notesMasterId r:id="rId6"/>
+    <p:notesMasterId r:id="rId15"/>
   </p:notesMasterIdLst>
   <p:sldIdLst>
     <p:sldId id="256" r:id="rId2"/>
     <p:sldId id="258" r:id="rId3"/>
     <p:sldId id="259" r:id="rId4"/>
-    <p:sldId id="260" r:id="rId5"/>
+    <p:sldId id="261" r:id="rId5"/>
+    <p:sldId id="264" r:id="rId6"/>
+    <p:sldId id="270" r:id="rId7"/>
+    <p:sldId id="265" r:id="rId8"/>
+    <p:sldId id="269" r:id="rId9"/>
+    <p:sldId id="266" r:id="rId10"/>
+    <p:sldId id="267" r:id="rId11"/>
+    <p:sldId id="262" r:id="rId12"/>
+    <p:sldId id="260" r:id="rId13"/>
+    <p:sldId id="263" r:id="rId14"/>
   </p:sldIdLst>
   <p:sldSz cx="12192000" cy="6858000"/>
   <p:notesSz cx="6858000" cy="9144000"/>
@@ -518,63 +527,114 @@
           <a:bodyPr/>
           <a:lstStyle/>
           <a:p>
-            <a:pPr marL="0" marR="0" indent="0" algn="l" defTabSz="914400" rtl="0" eaLnBrk="1" fontAlgn="auto" latinLnBrk="0" hangingPunct="1">
-              <a:lnSpc>
-                <a:spcPct val="100000"/>
-              </a:lnSpc>
-              <a:spcBef>
-                <a:spcPts val="0"/>
-              </a:spcBef>
-              <a:spcAft>
-                <a:spcPts val="0"/>
-              </a:spcAft>
-              <a:buClrTx/>
-              <a:buSzTx/>
-              <a:buFontTx/>
-              <a:buNone/>
-              <a:tabLst/>
-              <a:defRPr/>
-            </a:pPr>
-            <a:r>
-              <a:rPr lang="en-US" sz="2800" b="0" i="0" u="none" strike="noStrike" baseline="0" dirty="0">
-                <a:solidFill>
-                  <a:srgbClr val="E3E3E3"/>
-                </a:solidFill>
-                <a:effectLst/>
-                <a:latin typeface="Google Sans Text"/>
-              </a:rPr>
-              <a:t>Measuring and comparing a building’s energy use to similar buildings, past consumption, </a:t>
-            </a:r>
-          </a:p>
-          <a:p>
-            <a:pPr marL="0" marR="0" indent="0" algn="l" defTabSz="914400" rtl="0" eaLnBrk="1" fontAlgn="auto" latinLnBrk="0" hangingPunct="1">
-              <a:lnSpc>
-                <a:spcPct val="100000"/>
-              </a:lnSpc>
-              <a:spcBef>
-                <a:spcPts val="0"/>
-              </a:spcBef>
-              <a:spcAft>
-                <a:spcPts val="0"/>
-              </a:spcAft>
-              <a:buClrTx/>
-              <a:buSzTx/>
-              <a:buFontTx/>
-              <a:buNone/>
-              <a:tabLst/>
-              <a:defRPr/>
-            </a:pPr>
-            <a:r>
-              <a:rPr lang="en-US" sz="2800" b="0" i="0" u="none" strike="noStrike" baseline="0" dirty="0">
-                <a:solidFill>
-                  <a:srgbClr val="E3E3E3"/>
-                </a:solidFill>
-                <a:effectLst/>
-                <a:latin typeface="Google Sans Text"/>
-              </a:rPr>
-              <a:t>or a reference performance level.</a:t>
-            </a:r>
-          </a:p>
+            <a:endParaRPr lang="en-US"/>
+          </a:p>
+        </p:txBody>
+      </p:sp>
+      <p:sp>
+        <p:nvSpPr>
+          <p:cNvPr id="4" name="Slide Number Placeholder 3"/>
+          <p:cNvSpPr>
+            <a:spLocks noGrp="1"/>
+          </p:cNvSpPr>
+          <p:nvPr>
+            <p:ph type="sldNum" sz="quarter" idx="5"/>
+          </p:nvPr>
+        </p:nvSpPr>
+        <p:spPr/>
+        <p:txBody>
+          <a:bodyPr/>
+          <a:lstStyle/>
+          <a:p>
+            <a:fld id="{433F17CF-9CB7-1F41-9F3B-9D2A483692EC}" type="slidenum">
+              <a:rPr lang="en-US" smtClean="0"/>
+              <a:t>1</a:t>
+            </a:fld>
+            <a:endParaRPr lang="en-US"/>
+          </a:p>
+        </p:txBody>
+      </p:sp>
+    </p:spTree>
+    <p:extLst>
+      <p:ext uri="{BB962C8B-B14F-4D97-AF65-F5344CB8AC3E}">
+        <p14:creationId xmlns:p14="http://schemas.microsoft.com/office/powerpoint/2010/main" val="1613639659"/>
+      </p:ext>
+    </p:extLst>
+  </p:cSld>
+  <p:clrMapOvr>
+    <a:masterClrMapping/>
+  </p:clrMapOvr>
+</p:notes>
+</file>
+
+<file path=ppt/notesSlides/notesSlide10.xml><?xml version="1.0" encoding="utf-8"?>
+<p:notes xmlns:a="http://schemas.openxmlformats.org/drawingml/2006/main" xmlns:r="http://schemas.openxmlformats.org/officeDocument/2006/relationships" xmlns:p="http://schemas.openxmlformats.org/presentationml/2006/main">
+  <p:cSld>
+    <p:spTree>
+      <p:nvGrpSpPr>
+        <p:cNvPr id="1" name="">
+          <a:extLst>
+            <a:ext uri="{FF2B5EF4-FFF2-40B4-BE49-F238E27FC236}">
+              <a16:creationId xmlns:a16="http://schemas.microsoft.com/office/drawing/2014/main" id="{A01E1214-5F3E-9995-79BE-E6910CE01AB0}"/>
+            </a:ext>
+          </a:extLst>
+        </p:cNvPr>
+        <p:cNvGrpSpPr/>
+        <p:nvPr/>
+      </p:nvGrpSpPr>
+      <p:grpSpPr>
+        <a:xfrm>
+          <a:off x="0" y="0"/>
+          <a:ext cx="0" cy="0"/>
+          <a:chOff x="0" y="0"/>
+          <a:chExt cx="0" cy="0"/>
+        </a:xfrm>
+      </p:grpSpPr>
+      <p:sp>
+        <p:nvSpPr>
+          <p:cNvPr id="2" name="Slide Image Placeholder 1">
+            <a:extLst>
+              <a:ext uri="{FF2B5EF4-FFF2-40B4-BE49-F238E27FC236}">
+                <a16:creationId xmlns:a16="http://schemas.microsoft.com/office/drawing/2014/main" id="{48748E3D-8485-A512-4944-E95C45EA1852}"/>
+              </a:ext>
+            </a:extLst>
+          </p:cNvPr>
+          <p:cNvSpPr>
+            <a:spLocks noGrp="1" noRot="1" noChangeAspect="1"/>
+          </p:cNvSpPr>
+          <p:nvPr>
+            <p:ph type="sldImg"/>
+          </p:nvPr>
+        </p:nvSpPr>
+        <p:spPr/>
+        <p:txBody>
+          <a:bodyPr/>
+          <a:lstStyle/>
+          <a:p>
+            <a:endParaRPr lang="en-US"/>
+          </a:p>
+        </p:txBody>
+      </p:sp>
+      <p:sp>
+        <p:nvSpPr>
+          <p:cNvPr id="3" name="Notes Placeholder 2">
+            <a:extLst>
+              <a:ext uri="{FF2B5EF4-FFF2-40B4-BE49-F238E27FC236}">
+                <a16:creationId xmlns:a16="http://schemas.microsoft.com/office/drawing/2014/main" id="{32EAF338-312B-2C77-D02A-B086C3AEBDD7}"/>
+              </a:ext>
+            </a:extLst>
+          </p:cNvPr>
+          <p:cNvSpPr>
+            <a:spLocks noGrp="1"/>
+          </p:cNvSpPr>
+          <p:nvPr>
+            <p:ph type="body" idx="1"/>
+          </p:nvPr>
+        </p:nvSpPr>
+        <p:spPr/>
+        <p:txBody>
+          <a:bodyPr/>
+          <a:lstStyle/>
           <a:p>
             <a:pPr marL="0" marR="0" lvl="0" indent="0" algn="l" defTabSz="914400" rtl="0" eaLnBrk="1" fontAlgn="auto" latinLnBrk="0" hangingPunct="1">
               <a:lnSpc>
@@ -594,58 +654,24 @@
               <a:defRPr/>
             </a:pPr>
             <a:r>
-              <a:rPr lang="en-US" sz="2800" dirty="0"/>
-              <a:t>Energy Star: 1–100 score, which rates energy performance in comparison to </a:t>
-            </a:r>
-          </a:p>
-          <a:p>
-            <a:pPr marL="0" marR="0" lvl="0" indent="0" algn="l" defTabSz="914400" rtl="0" eaLnBrk="1" fontAlgn="auto" latinLnBrk="0" hangingPunct="1">
-              <a:lnSpc>
-                <a:spcPct val="100000"/>
-              </a:lnSpc>
-              <a:spcBef>
-                <a:spcPts val="0"/>
-              </a:spcBef>
-              <a:spcAft>
-                <a:spcPts val="0"/>
-              </a:spcAft>
-              <a:buClrTx/>
-              <a:buSzTx/>
-              <a:buFontTx/>
-              <a:buNone/>
-              <a:tabLst/>
-              <a:defRPr/>
-            </a:pPr>
-            <a:r>
-              <a:rPr lang="en-US" sz="2800" dirty="0"/>
-              <a:t>similar buildings across the country</a:t>
-            </a:r>
-          </a:p>
-          <a:p>
-            <a:pPr marL="0" marR="0" indent="0" algn="l" defTabSz="914400" rtl="0" eaLnBrk="1" fontAlgn="auto" latinLnBrk="0" hangingPunct="1">
-              <a:lnSpc>
-                <a:spcPct val="100000"/>
-              </a:lnSpc>
-              <a:spcBef>
-                <a:spcPts val="0"/>
-              </a:spcBef>
-              <a:spcAft>
-                <a:spcPts val="0"/>
-              </a:spcAft>
-              <a:buClrTx/>
-              <a:buSzTx/>
-              <a:buFontTx/>
-              <a:buNone/>
-              <a:tabLst/>
-              <a:defRPr/>
-            </a:pPr>
-            <a:endParaRPr lang="en-US" sz="2800" baseline="0" dirty="0"/>
-          </a:p>
-        </p:txBody>
-      </p:sp>
-      <p:sp>
-        <p:nvSpPr>
-          <p:cNvPr id="4" name="Slide Number Placeholder 3"/>
+              <a:rPr lang="en-US" sz="1200" dirty="0"/>
+              <a:t>Entries had missing ID numbers and addresses, but some had electricity use and Total GHG Emissions</a:t>
+            </a:r>
+          </a:p>
+          <a:p>
+            <a:endParaRPr lang="en-US" dirty="0"/>
+          </a:p>
+        </p:txBody>
+      </p:sp>
+      <p:sp>
+        <p:nvSpPr>
+          <p:cNvPr id="4" name="Slide Number Placeholder 3">
+            <a:extLst>
+              <a:ext uri="{FF2B5EF4-FFF2-40B4-BE49-F238E27FC236}">
+                <a16:creationId xmlns:a16="http://schemas.microsoft.com/office/drawing/2014/main" id="{C69737AA-B41B-5DCC-44C0-A16D648C25FF}"/>
+              </a:ext>
+            </a:extLst>
+          </p:cNvPr>
           <p:cNvSpPr>
             <a:spLocks noGrp="1"/>
           </p:cNvSpPr>
@@ -660,7 +686,7 @@
           <a:p>
             <a:fld id="{433F17CF-9CB7-1F41-9F3B-9D2A483692EC}" type="slidenum">
               <a:rPr lang="en-US" smtClean="0"/>
-              <a:t>3</a:t>
+              <a:t>11</a:t>
             </a:fld>
             <a:endParaRPr lang="en-US"/>
           </a:p>
@@ -669,7 +695,213 @@
     </p:spTree>
     <p:extLst>
       <p:ext uri="{BB962C8B-B14F-4D97-AF65-F5344CB8AC3E}">
-        <p14:creationId xmlns:p14="http://schemas.microsoft.com/office/powerpoint/2010/main" val="2176010800"/>
+        <p14:creationId xmlns:p14="http://schemas.microsoft.com/office/powerpoint/2010/main" val="110592694"/>
+      </p:ext>
+    </p:extLst>
+  </p:cSld>
+  <p:clrMapOvr>
+    <a:masterClrMapping/>
+  </p:clrMapOvr>
+</p:notes>
+</file>
+
+<file path=ppt/notesSlides/notesSlide11.xml><?xml version="1.0" encoding="utf-8"?>
+<p:notes xmlns:a="http://schemas.openxmlformats.org/drawingml/2006/main" xmlns:r="http://schemas.openxmlformats.org/officeDocument/2006/relationships" xmlns:p="http://schemas.openxmlformats.org/presentationml/2006/main">
+  <p:cSld>
+    <p:spTree>
+      <p:nvGrpSpPr>
+        <p:cNvPr id="1" name=""/>
+        <p:cNvGrpSpPr/>
+        <p:nvPr/>
+      </p:nvGrpSpPr>
+      <p:grpSpPr>
+        <a:xfrm>
+          <a:off x="0" y="0"/>
+          <a:ext cx="0" cy="0"/>
+          <a:chOff x="0" y="0"/>
+          <a:chExt cx="0" cy="0"/>
+        </a:xfrm>
+      </p:grpSpPr>
+      <p:sp>
+        <p:nvSpPr>
+          <p:cNvPr id="2" name="Slide Image Placeholder 1"/>
+          <p:cNvSpPr>
+            <a:spLocks noGrp="1" noRot="1" noChangeAspect="1"/>
+          </p:cNvSpPr>
+          <p:nvPr>
+            <p:ph type="sldImg"/>
+          </p:nvPr>
+        </p:nvSpPr>
+        <p:spPr/>
+        <p:txBody>
+          <a:bodyPr/>
+          <a:lstStyle/>
+          <a:p>
+            <a:endParaRPr lang="en-US"/>
+          </a:p>
+        </p:txBody>
+      </p:sp>
+      <p:sp>
+        <p:nvSpPr>
+          <p:cNvPr id="3" name="Notes Placeholder 2"/>
+          <p:cNvSpPr>
+            <a:spLocks noGrp="1"/>
+          </p:cNvSpPr>
+          <p:nvPr>
+            <p:ph type="body" idx="1"/>
+          </p:nvPr>
+        </p:nvSpPr>
+        <p:spPr/>
+        <p:txBody>
+          <a:bodyPr/>
+          <a:lstStyle/>
+          <a:p>
+            <a:endParaRPr lang="en-US" dirty="0"/>
+          </a:p>
+        </p:txBody>
+      </p:sp>
+      <p:sp>
+        <p:nvSpPr>
+          <p:cNvPr id="4" name="Slide Number Placeholder 3"/>
+          <p:cNvSpPr>
+            <a:spLocks noGrp="1"/>
+          </p:cNvSpPr>
+          <p:nvPr>
+            <p:ph type="sldNum" sz="quarter" idx="5"/>
+          </p:nvPr>
+        </p:nvSpPr>
+        <p:spPr/>
+        <p:txBody>
+          <a:bodyPr/>
+          <a:lstStyle/>
+          <a:p>
+            <a:fld id="{433F17CF-9CB7-1F41-9F3B-9D2A483692EC}" type="slidenum">
+              <a:rPr lang="en-US" smtClean="0"/>
+              <a:t>12</a:t>
+            </a:fld>
+            <a:endParaRPr lang="en-US"/>
+          </a:p>
+        </p:txBody>
+      </p:sp>
+    </p:spTree>
+    <p:extLst>
+      <p:ext uri="{BB962C8B-B14F-4D97-AF65-F5344CB8AC3E}">
+        <p14:creationId xmlns:p14="http://schemas.microsoft.com/office/powerpoint/2010/main" val="3353820539"/>
+      </p:ext>
+    </p:extLst>
+  </p:cSld>
+  <p:clrMapOvr>
+    <a:masterClrMapping/>
+  </p:clrMapOvr>
+</p:notes>
+</file>
+
+<file path=ppt/notesSlides/notesSlide12.xml><?xml version="1.0" encoding="utf-8"?>
+<p:notes xmlns:a="http://schemas.openxmlformats.org/drawingml/2006/main" xmlns:r="http://schemas.openxmlformats.org/officeDocument/2006/relationships" xmlns:p="http://schemas.openxmlformats.org/presentationml/2006/main">
+  <p:cSld>
+    <p:spTree>
+      <p:nvGrpSpPr>
+        <p:cNvPr id="1" name="">
+          <a:extLst>
+            <a:ext uri="{FF2B5EF4-FFF2-40B4-BE49-F238E27FC236}">
+              <a16:creationId xmlns:a16="http://schemas.microsoft.com/office/drawing/2014/main" id="{C54E6ABC-25EA-83F5-C2E5-D51BD39A9972}"/>
+            </a:ext>
+          </a:extLst>
+        </p:cNvPr>
+        <p:cNvGrpSpPr/>
+        <p:nvPr/>
+      </p:nvGrpSpPr>
+      <p:grpSpPr>
+        <a:xfrm>
+          <a:off x="0" y="0"/>
+          <a:ext cx="0" cy="0"/>
+          <a:chOff x="0" y="0"/>
+          <a:chExt cx="0" cy="0"/>
+        </a:xfrm>
+      </p:grpSpPr>
+      <p:sp>
+        <p:nvSpPr>
+          <p:cNvPr id="2" name="Slide Image Placeholder 1">
+            <a:extLst>
+              <a:ext uri="{FF2B5EF4-FFF2-40B4-BE49-F238E27FC236}">
+                <a16:creationId xmlns:a16="http://schemas.microsoft.com/office/drawing/2014/main" id="{12D8DD14-301C-7BC0-08A5-D3346DC24E59}"/>
+              </a:ext>
+            </a:extLst>
+          </p:cNvPr>
+          <p:cNvSpPr>
+            <a:spLocks noGrp="1" noRot="1" noChangeAspect="1"/>
+          </p:cNvSpPr>
+          <p:nvPr>
+            <p:ph type="sldImg"/>
+          </p:nvPr>
+        </p:nvSpPr>
+        <p:spPr/>
+        <p:txBody>
+          <a:bodyPr/>
+          <a:lstStyle/>
+          <a:p>
+            <a:endParaRPr lang="en-US"/>
+          </a:p>
+        </p:txBody>
+      </p:sp>
+      <p:sp>
+        <p:nvSpPr>
+          <p:cNvPr id="3" name="Notes Placeholder 2">
+            <a:extLst>
+              <a:ext uri="{FF2B5EF4-FFF2-40B4-BE49-F238E27FC236}">
+                <a16:creationId xmlns:a16="http://schemas.microsoft.com/office/drawing/2014/main" id="{3BBE2E3C-2D4D-F044-A5C4-C00E6858E4E3}"/>
+              </a:ext>
+            </a:extLst>
+          </p:cNvPr>
+          <p:cNvSpPr>
+            <a:spLocks noGrp="1"/>
+          </p:cNvSpPr>
+          <p:nvPr>
+            <p:ph type="body" idx="1"/>
+          </p:nvPr>
+        </p:nvSpPr>
+        <p:spPr/>
+        <p:txBody>
+          <a:bodyPr/>
+          <a:lstStyle/>
+          <a:p>
+            <a:endParaRPr lang="en-US" dirty="0"/>
+          </a:p>
+        </p:txBody>
+      </p:sp>
+      <p:sp>
+        <p:nvSpPr>
+          <p:cNvPr id="4" name="Slide Number Placeholder 3">
+            <a:extLst>
+              <a:ext uri="{FF2B5EF4-FFF2-40B4-BE49-F238E27FC236}">
+                <a16:creationId xmlns:a16="http://schemas.microsoft.com/office/drawing/2014/main" id="{7882A0D8-AB80-56E6-1EA0-8F97654EFEA7}"/>
+              </a:ext>
+            </a:extLst>
+          </p:cNvPr>
+          <p:cNvSpPr>
+            <a:spLocks noGrp="1"/>
+          </p:cNvSpPr>
+          <p:nvPr>
+            <p:ph type="sldNum" sz="quarter" idx="5"/>
+          </p:nvPr>
+        </p:nvSpPr>
+        <p:spPr/>
+        <p:txBody>
+          <a:bodyPr/>
+          <a:lstStyle/>
+          <a:p>
+            <a:fld id="{433F17CF-9CB7-1F41-9F3B-9D2A483692EC}" type="slidenum">
+              <a:rPr lang="en-US" smtClean="0"/>
+              <a:t>13</a:t>
+            </a:fld>
+            <a:endParaRPr lang="en-US"/>
+          </a:p>
+        </p:txBody>
+      </p:sp>
+    </p:spTree>
+    <p:extLst>
+      <p:ext uri="{BB962C8B-B14F-4D97-AF65-F5344CB8AC3E}">
+        <p14:creationId xmlns:p14="http://schemas.microsoft.com/office/powerpoint/2010/main" val="467693578"/>
       </p:ext>
     </p:extLst>
   </p:cSld>
@@ -730,7 +962,219 @@
           <a:bodyPr/>
           <a:lstStyle/>
           <a:p>
+            <a:pPr marL="0" marR="0" indent="0" algn="l" defTabSz="914400" rtl="0" eaLnBrk="1" fontAlgn="auto" latinLnBrk="0" hangingPunct="1">
+              <a:lnSpc>
+                <a:spcPct val="100000"/>
+              </a:lnSpc>
+              <a:spcBef>
+                <a:spcPts val="0"/>
+              </a:spcBef>
+              <a:spcAft>
+                <a:spcPts val="0"/>
+              </a:spcAft>
+              <a:buClrTx/>
+              <a:buSzTx/>
+              <a:buFontTx/>
+              <a:buNone/>
+              <a:tabLst/>
+              <a:defRPr/>
+            </a:pPr>
+            <a:r>
+              <a:rPr lang="en-US" sz="2800" b="0" i="0" u="none" strike="noStrike" baseline="0" dirty="0">
+                <a:solidFill>
+                  <a:srgbClr val="E3E3E3"/>
+                </a:solidFill>
+                <a:effectLst/>
+                <a:latin typeface="Google Sans Text"/>
+              </a:rPr>
+              <a:t>Measuring and comparing a building’s energy use to similar buildings, past consumption, </a:t>
+            </a:r>
+          </a:p>
+          <a:p>
+            <a:pPr marL="0" marR="0" indent="0" algn="l" defTabSz="914400" rtl="0" eaLnBrk="1" fontAlgn="auto" latinLnBrk="0" hangingPunct="1">
+              <a:lnSpc>
+                <a:spcPct val="100000"/>
+              </a:lnSpc>
+              <a:spcBef>
+                <a:spcPts val="0"/>
+              </a:spcBef>
+              <a:spcAft>
+                <a:spcPts val="0"/>
+              </a:spcAft>
+              <a:buClrTx/>
+              <a:buSzTx/>
+              <a:buFontTx/>
+              <a:buNone/>
+              <a:tabLst/>
+              <a:defRPr/>
+            </a:pPr>
+            <a:r>
+              <a:rPr lang="en-US" sz="2800" b="0" i="0" u="none" strike="noStrike" baseline="0" dirty="0">
+                <a:solidFill>
+                  <a:srgbClr val="E3E3E3"/>
+                </a:solidFill>
+                <a:effectLst/>
+                <a:latin typeface="Google Sans Text"/>
+              </a:rPr>
+              <a:t>or a reference performance level.</a:t>
+            </a:r>
+          </a:p>
+          <a:p>
+            <a:pPr marL="0" marR="0" indent="0" algn="l" defTabSz="914400" rtl="0" eaLnBrk="1" fontAlgn="auto" latinLnBrk="0" hangingPunct="1">
+              <a:lnSpc>
+                <a:spcPct val="100000"/>
+              </a:lnSpc>
+              <a:spcBef>
+                <a:spcPts val="0"/>
+              </a:spcBef>
+              <a:spcAft>
+                <a:spcPts val="0"/>
+              </a:spcAft>
+              <a:buClrTx/>
+              <a:buSzTx/>
+              <a:buFontTx/>
+              <a:buNone/>
+              <a:tabLst/>
+              <a:defRPr/>
+            </a:pPr>
+            <a:endParaRPr lang="en-US" sz="2800" baseline="0" dirty="0"/>
+          </a:p>
+        </p:txBody>
+      </p:sp>
+      <p:sp>
+        <p:nvSpPr>
+          <p:cNvPr id="4" name="Slide Number Placeholder 3"/>
+          <p:cNvSpPr>
+            <a:spLocks noGrp="1"/>
+          </p:cNvSpPr>
+          <p:nvPr>
+            <p:ph type="sldNum" sz="quarter" idx="5"/>
+          </p:nvPr>
+        </p:nvSpPr>
+        <p:spPr/>
+        <p:txBody>
+          <a:bodyPr/>
+          <a:lstStyle/>
+          <a:p>
+            <a:fld id="{433F17CF-9CB7-1F41-9F3B-9D2A483692EC}" type="slidenum">
+              <a:rPr lang="en-US" smtClean="0"/>
+              <a:t>3</a:t>
+            </a:fld>
             <a:endParaRPr lang="en-US"/>
+          </a:p>
+        </p:txBody>
+      </p:sp>
+    </p:spTree>
+    <p:extLst>
+      <p:ext uri="{BB962C8B-B14F-4D97-AF65-F5344CB8AC3E}">
+        <p14:creationId xmlns:p14="http://schemas.microsoft.com/office/powerpoint/2010/main" val="2176010800"/>
+      </p:ext>
+    </p:extLst>
+  </p:cSld>
+  <p:clrMapOvr>
+    <a:masterClrMapping/>
+  </p:clrMapOvr>
+</p:notes>
+</file>
+
+<file path=ppt/notesSlides/notesSlide3.xml><?xml version="1.0" encoding="utf-8"?>
+<p:notes xmlns:a="http://schemas.openxmlformats.org/drawingml/2006/main" xmlns:r="http://schemas.openxmlformats.org/officeDocument/2006/relationships" xmlns:p="http://schemas.openxmlformats.org/presentationml/2006/main">
+  <p:cSld>
+    <p:spTree>
+      <p:nvGrpSpPr>
+        <p:cNvPr id="1" name=""/>
+        <p:cNvGrpSpPr/>
+        <p:nvPr/>
+      </p:nvGrpSpPr>
+      <p:grpSpPr>
+        <a:xfrm>
+          <a:off x="0" y="0"/>
+          <a:ext cx="0" cy="0"/>
+          <a:chOff x="0" y="0"/>
+          <a:chExt cx="0" cy="0"/>
+        </a:xfrm>
+      </p:grpSpPr>
+      <p:sp>
+        <p:nvSpPr>
+          <p:cNvPr id="2" name="Slide Image Placeholder 1"/>
+          <p:cNvSpPr>
+            <a:spLocks noGrp="1" noRot="1" noChangeAspect="1"/>
+          </p:cNvSpPr>
+          <p:nvPr>
+            <p:ph type="sldImg"/>
+          </p:nvPr>
+        </p:nvSpPr>
+        <p:spPr/>
+        <p:txBody>
+          <a:bodyPr/>
+          <a:lstStyle/>
+          <a:p>
+            <a:endParaRPr lang="en-US"/>
+          </a:p>
+        </p:txBody>
+      </p:sp>
+      <p:sp>
+        <p:nvSpPr>
+          <p:cNvPr id="3" name="Notes Placeholder 2"/>
+          <p:cNvSpPr>
+            <a:spLocks noGrp="1"/>
+          </p:cNvSpPr>
+          <p:nvPr>
+            <p:ph type="body" idx="1"/>
+          </p:nvPr>
+        </p:nvSpPr>
+        <p:spPr/>
+        <p:txBody>
+          <a:bodyPr/>
+          <a:lstStyle/>
+          <a:p>
+            <a:pPr marL="0" marR="0" lvl="0" indent="0" algn="l" defTabSz="914400" rtl="0" eaLnBrk="1" fontAlgn="auto" latinLnBrk="0" hangingPunct="1">
+              <a:lnSpc>
+                <a:spcPct val="100000"/>
+              </a:lnSpc>
+              <a:spcBef>
+                <a:spcPts val="0"/>
+              </a:spcBef>
+              <a:spcAft>
+                <a:spcPts val="0"/>
+              </a:spcAft>
+              <a:buClrTx/>
+              <a:buSzTx/>
+              <a:buFontTx/>
+              <a:buNone/>
+              <a:tabLst/>
+              <a:defRPr/>
+            </a:pPr>
+            <a:r>
+              <a:rPr lang="en-US" sz="2800" dirty="0"/>
+              <a:t>Entries had missing ID numbers and addresses, but most had electricity use, </a:t>
+            </a:r>
+          </a:p>
+          <a:p>
+            <a:pPr marL="0" marR="0" lvl="0" indent="0" algn="l" defTabSz="914400" rtl="0" eaLnBrk="1" fontAlgn="auto" latinLnBrk="0" hangingPunct="1">
+              <a:lnSpc>
+                <a:spcPct val="100000"/>
+              </a:lnSpc>
+              <a:spcBef>
+                <a:spcPts val="0"/>
+              </a:spcBef>
+              <a:spcAft>
+                <a:spcPts val="0"/>
+              </a:spcAft>
+              <a:buClrTx/>
+              <a:buSzTx/>
+              <a:buFontTx/>
+              <a:buNone/>
+              <a:tabLst/>
+              <a:defRPr/>
+            </a:pPr>
+            <a:r>
+              <a:rPr lang="en-US" sz="2800" dirty="0"/>
+              <a:t>floor area, and Total GHG Emissions</a:t>
+            </a:r>
+          </a:p>
+          <a:p>
+            <a:endParaRPr lang="en-US" dirty="0"/>
           </a:p>
         </p:txBody>
       </p:sp>
@@ -760,7 +1204,914 @@
     </p:spTree>
     <p:extLst>
       <p:ext uri="{BB962C8B-B14F-4D97-AF65-F5344CB8AC3E}">
-        <p14:creationId xmlns:p14="http://schemas.microsoft.com/office/powerpoint/2010/main" val="3353820539"/>
+        <p14:creationId xmlns:p14="http://schemas.microsoft.com/office/powerpoint/2010/main" val="1047691007"/>
+      </p:ext>
+    </p:extLst>
+  </p:cSld>
+  <p:clrMapOvr>
+    <a:masterClrMapping/>
+  </p:clrMapOvr>
+</p:notes>
+</file>
+
+<file path=ppt/notesSlides/notesSlide4.xml><?xml version="1.0" encoding="utf-8"?>
+<p:notes xmlns:a="http://schemas.openxmlformats.org/drawingml/2006/main" xmlns:r="http://schemas.openxmlformats.org/officeDocument/2006/relationships" xmlns:p="http://schemas.openxmlformats.org/presentationml/2006/main">
+  <p:cSld>
+    <p:spTree>
+      <p:nvGrpSpPr>
+        <p:cNvPr id="1" name="">
+          <a:extLst>
+            <a:ext uri="{FF2B5EF4-FFF2-40B4-BE49-F238E27FC236}">
+              <a16:creationId xmlns:a16="http://schemas.microsoft.com/office/drawing/2014/main" id="{80C81B58-F2C0-5F64-297C-0DE2E14A16BA}"/>
+            </a:ext>
+          </a:extLst>
+        </p:cNvPr>
+        <p:cNvGrpSpPr/>
+        <p:nvPr/>
+      </p:nvGrpSpPr>
+      <p:grpSpPr>
+        <a:xfrm>
+          <a:off x="0" y="0"/>
+          <a:ext cx="0" cy="0"/>
+          <a:chOff x="0" y="0"/>
+          <a:chExt cx="0" cy="0"/>
+        </a:xfrm>
+      </p:grpSpPr>
+      <p:sp>
+        <p:nvSpPr>
+          <p:cNvPr id="2" name="Slide Image Placeholder 1">
+            <a:extLst>
+              <a:ext uri="{FF2B5EF4-FFF2-40B4-BE49-F238E27FC236}">
+                <a16:creationId xmlns:a16="http://schemas.microsoft.com/office/drawing/2014/main" id="{7636CA9B-9882-EAEC-F1BB-F0611BDC2B22}"/>
+              </a:ext>
+            </a:extLst>
+          </p:cNvPr>
+          <p:cNvSpPr>
+            <a:spLocks noGrp="1" noRot="1" noChangeAspect="1"/>
+          </p:cNvSpPr>
+          <p:nvPr>
+            <p:ph type="sldImg"/>
+          </p:nvPr>
+        </p:nvSpPr>
+        <p:spPr/>
+        <p:txBody>
+          <a:bodyPr/>
+          <a:lstStyle/>
+          <a:p>
+            <a:endParaRPr lang="en-US"/>
+          </a:p>
+        </p:txBody>
+      </p:sp>
+      <p:sp>
+        <p:nvSpPr>
+          <p:cNvPr id="3" name="Notes Placeholder 2">
+            <a:extLst>
+              <a:ext uri="{FF2B5EF4-FFF2-40B4-BE49-F238E27FC236}">
+                <a16:creationId xmlns:a16="http://schemas.microsoft.com/office/drawing/2014/main" id="{B7DABCC8-A7D4-0158-1A3F-146D53CBF8B4}"/>
+              </a:ext>
+            </a:extLst>
+          </p:cNvPr>
+          <p:cNvSpPr>
+            <a:spLocks noGrp="1"/>
+          </p:cNvSpPr>
+          <p:nvPr>
+            <p:ph type="body" idx="1"/>
+          </p:nvPr>
+        </p:nvSpPr>
+        <p:spPr/>
+        <p:txBody>
+          <a:bodyPr/>
+          <a:lstStyle/>
+          <a:p>
+            <a:pPr marL="0" marR="0" lvl="0" indent="0" algn="l" defTabSz="914400" rtl="0" eaLnBrk="1" fontAlgn="auto" latinLnBrk="0" hangingPunct="1">
+              <a:lnSpc>
+                <a:spcPct val="100000"/>
+              </a:lnSpc>
+              <a:spcBef>
+                <a:spcPts val="0"/>
+              </a:spcBef>
+              <a:spcAft>
+                <a:spcPts val="0"/>
+              </a:spcAft>
+              <a:buClrTx/>
+              <a:buSzTx/>
+              <a:buFontTx/>
+              <a:buNone/>
+              <a:tabLst/>
+              <a:defRPr/>
+            </a:pPr>
+            <a:r>
+              <a:rPr lang="en-US" sz="2400" b="0" kern="1200" dirty="0">
+                <a:solidFill>
+                  <a:schemeClr val="tx1"/>
+                </a:solidFill>
+                <a:effectLst/>
+                <a:latin typeface="+mn-lt"/>
+                <a:ea typeface="+mn-ea"/>
+                <a:cs typeface="+mn-cs"/>
+              </a:rPr>
+              <a:t>Note NaN</a:t>
+            </a:r>
+          </a:p>
+          <a:p>
+            <a:pPr marL="0" marR="0" lvl="0" indent="0" algn="l" defTabSz="914400" rtl="0" eaLnBrk="1" fontAlgn="auto" latinLnBrk="0" hangingPunct="1">
+              <a:lnSpc>
+                <a:spcPct val="100000"/>
+              </a:lnSpc>
+              <a:spcBef>
+                <a:spcPts val="0"/>
+              </a:spcBef>
+              <a:spcAft>
+                <a:spcPts val="0"/>
+              </a:spcAft>
+              <a:buClrTx/>
+              <a:buSzTx/>
+              <a:buFontTx/>
+              <a:buNone/>
+              <a:tabLst/>
+              <a:defRPr/>
+            </a:pPr>
+            <a:r>
+              <a:rPr lang="en-US" sz="2400" b="0" kern="1200" dirty="0">
+                <a:solidFill>
+                  <a:schemeClr val="tx1"/>
+                </a:solidFill>
+                <a:effectLst/>
+                <a:latin typeface="+mn-lt"/>
+                <a:ea typeface="+mn-ea"/>
+                <a:cs typeface="+mn-cs"/>
+              </a:rPr>
+              <a:t>Other: supermarket or grocery store, retail store, senior living community, </a:t>
+            </a:r>
+          </a:p>
+          <a:p>
+            <a:pPr marL="0" marR="0" lvl="0" indent="0" algn="l" defTabSz="914400" rtl="0" eaLnBrk="1" fontAlgn="auto" latinLnBrk="0" hangingPunct="1">
+              <a:lnSpc>
+                <a:spcPct val="100000"/>
+              </a:lnSpc>
+              <a:spcBef>
+                <a:spcPts val="0"/>
+              </a:spcBef>
+              <a:spcAft>
+                <a:spcPts val="0"/>
+              </a:spcAft>
+              <a:buClrTx/>
+              <a:buSzTx/>
+              <a:buFontTx/>
+              <a:buNone/>
+              <a:tabLst/>
+              <a:defRPr/>
+            </a:pPr>
+            <a:r>
+              <a:rPr lang="en-US" sz="2400" b="0" kern="1200" dirty="0">
+                <a:solidFill>
+                  <a:schemeClr val="tx1"/>
+                </a:solidFill>
+                <a:effectLst/>
+                <a:latin typeface="+mn-lt"/>
+                <a:ea typeface="+mn-ea"/>
+                <a:cs typeface="+mn-cs"/>
+              </a:rPr>
+              <a:t>car dealership, mixed use property, laboratory, strip mall</a:t>
+            </a:r>
+          </a:p>
+          <a:p>
+            <a:endParaRPr lang="en-US" dirty="0"/>
+          </a:p>
+        </p:txBody>
+      </p:sp>
+      <p:sp>
+        <p:nvSpPr>
+          <p:cNvPr id="4" name="Slide Number Placeholder 3">
+            <a:extLst>
+              <a:ext uri="{FF2B5EF4-FFF2-40B4-BE49-F238E27FC236}">
+                <a16:creationId xmlns:a16="http://schemas.microsoft.com/office/drawing/2014/main" id="{D9789977-CF80-83E4-5426-4E6624C14130}"/>
+              </a:ext>
+            </a:extLst>
+          </p:cNvPr>
+          <p:cNvSpPr>
+            <a:spLocks noGrp="1"/>
+          </p:cNvSpPr>
+          <p:nvPr>
+            <p:ph type="sldNum" sz="quarter" idx="5"/>
+          </p:nvPr>
+        </p:nvSpPr>
+        <p:spPr/>
+        <p:txBody>
+          <a:bodyPr/>
+          <a:lstStyle/>
+          <a:p>
+            <a:fld id="{433F17CF-9CB7-1F41-9F3B-9D2A483692EC}" type="slidenum">
+              <a:rPr lang="en-US" smtClean="0"/>
+              <a:t>5</a:t>
+            </a:fld>
+            <a:endParaRPr lang="en-US"/>
+          </a:p>
+        </p:txBody>
+      </p:sp>
+    </p:spTree>
+    <p:extLst>
+      <p:ext uri="{BB962C8B-B14F-4D97-AF65-F5344CB8AC3E}">
+        <p14:creationId xmlns:p14="http://schemas.microsoft.com/office/powerpoint/2010/main" val="1199720402"/>
+      </p:ext>
+    </p:extLst>
+  </p:cSld>
+  <p:clrMapOvr>
+    <a:masterClrMapping/>
+  </p:clrMapOvr>
+</p:notes>
+</file>
+
+<file path=ppt/notesSlides/notesSlide5.xml><?xml version="1.0" encoding="utf-8"?>
+<p:notes xmlns:a="http://schemas.openxmlformats.org/drawingml/2006/main" xmlns:r="http://schemas.openxmlformats.org/officeDocument/2006/relationships" xmlns:p="http://schemas.openxmlformats.org/presentationml/2006/main">
+  <p:cSld>
+    <p:spTree>
+      <p:nvGrpSpPr>
+        <p:cNvPr id="1" name="">
+          <a:extLst>
+            <a:ext uri="{FF2B5EF4-FFF2-40B4-BE49-F238E27FC236}">
+              <a16:creationId xmlns:a16="http://schemas.microsoft.com/office/drawing/2014/main" id="{94AB6714-2614-03CA-F8EA-8D68C004F5F4}"/>
+            </a:ext>
+          </a:extLst>
+        </p:cNvPr>
+        <p:cNvGrpSpPr/>
+        <p:nvPr/>
+      </p:nvGrpSpPr>
+      <p:grpSpPr>
+        <a:xfrm>
+          <a:off x="0" y="0"/>
+          <a:ext cx="0" cy="0"/>
+          <a:chOff x="0" y="0"/>
+          <a:chExt cx="0" cy="0"/>
+        </a:xfrm>
+      </p:grpSpPr>
+      <p:sp>
+        <p:nvSpPr>
+          <p:cNvPr id="2" name="Slide Image Placeholder 1">
+            <a:extLst>
+              <a:ext uri="{FF2B5EF4-FFF2-40B4-BE49-F238E27FC236}">
+                <a16:creationId xmlns:a16="http://schemas.microsoft.com/office/drawing/2014/main" id="{1A4C2F13-0E02-E455-7D7D-4B078092AD81}"/>
+              </a:ext>
+            </a:extLst>
+          </p:cNvPr>
+          <p:cNvSpPr>
+            <a:spLocks noGrp="1" noRot="1" noChangeAspect="1"/>
+          </p:cNvSpPr>
+          <p:nvPr>
+            <p:ph type="sldImg"/>
+          </p:nvPr>
+        </p:nvSpPr>
+        <p:spPr/>
+        <p:txBody>
+          <a:bodyPr/>
+          <a:lstStyle/>
+          <a:p>
+            <a:endParaRPr lang="en-US"/>
+          </a:p>
+        </p:txBody>
+      </p:sp>
+      <p:sp>
+        <p:nvSpPr>
+          <p:cNvPr id="3" name="Notes Placeholder 2">
+            <a:extLst>
+              <a:ext uri="{FF2B5EF4-FFF2-40B4-BE49-F238E27FC236}">
+                <a16:creationId xmlns:a16="http://schemas.microsoft.com/office/drawing/2014/main" id="{8AA9533F-8C91-DD49-0CED-086AE0451D1D}"/>
+              </a:ext>
+            </a:extLst>
+          </p:cNvPr>
+          <p:cNvSpPr>
+            <a:spLocks noGrp="1"/>
+          </p:cNvSpPr>
+          <p:nvPr>
+            <p:ph type="body" idx="1"/>
+          </p:nvPr>
+        </p:nvSpPr>
+        <p:spPr/>
+        <p:txBody>
+          <a:bodyPr/>
+          <a:lstStyle/>
+          <a:p>
+            <a:pPr marL="0" marR="0" lvl="0" indent="0" algn="l" defTabSz="914400" rtl="0" eaLnBrk="1" fontAlgn="auto" latinLnBrk="0" hangingPunct="1">
+              <a:lnSpc>
+                <a:spcPct val="100000"/>
+              </a:lnSpc>
+              <a:spcBef>
+                <a:spcPts val="0"/>
+              </a:spcBef>
+              <a:spcAft>
+                <a:spcPts val="0"/>
+              </a:spcAft>
+              <a:buClrTx/>
+              <a:buSzTx/>
+              <a:buFontTx/>
+              <a:buNone/>
+              <a:tabLst/>
+              <a:defRPr/>
+            </a:pPr>
+            <a:r>
+              <a:rPr lang="en-US" sz="2400" dirty="0"/>
+              <a:t>Energy Star: 1–100 score, which rates energy performance in comparison to </a:t>
+            </a:r>
+          </a:p>
+          <a:p>
+            <a:pPr marL="0" marR="0" lvl="0" indent="0" algn="l" defTabSz="914400" rtl="0" eaLnBrk="1" fontAlgn="auto" latinLnBrk="0" hangingPunct="1">
+              <a:lnSpc>
+                <a:spcPct val="100000"/>
+              </a:lnSpc>
+              <a:spcBef>
+                <a:spcPts val="0"/>
+              </a:spcBef>
+              <a:spcAft>
+                <a:spcPts val="0"/>
+              </a:spcAft>
+              <a:buClrTx/>
+              <a:buSzTx/>
+              <a:buFontTx/>
+              <a:buNone/>
+              <a:tabLst/>
+              <a:defRPr/>
+            </a:pPr>
+            <a:r>
+              <a:rPr lang="en-US" sz="2400" dirty="0"/>
+              <a:t>similar buildings across the country</a:t>
+            </a:r>
+          </a:p>
+          <a:p>
+            <a:endParaRPr lang="en-US" dirty="0"/>
+          </a:p>
+        </p:txBody>
+      </p:sp>
+      <p:sp>
+        <p:nvSpPr>
+          <p:cNvPr id="4" name="Slide Number Placeholder 3">
+            <a:extLst>
+              <a:ext uri="{FF2B5EF4-FFF2-40B4-BE49-F238E27FC236}">
+                <a16:creationId xmlns:a16="http://schemas.microsoft.com/office/drawing/2014/main" id="{5089EDCE-B8FA-0803-53D8-4482E6A54600}"/>
+              </a:ext>
+            </a:extLst>
+          </p:cNvPr>
+          <p:cNvSpPr>
+            <a:spLocks noGrp="1"/>
+          </p:cNvSpPr>
+          <p:nvPr>
+            <p:ph type="sldNum" sz="quarter" idx="5"/>
+          </p:nvPr>
+        </p:nvSpPr>
+        <p:spPr/>
+        <p:txBody>
+          <a:bodyPr/>
+          <a:lstStyle/>
+          <a:p>
+            <a:fld id="{433F17CF-9CB7-1F41-9F3B-9D2A483692EC}" type="slidenum">
+              <a:rPr lang="en-US" smtClean="0"/>
+              <a:t>6</a:t>
+            </a:fld>
+            <a:endParaRPr lang="en-US"/>
+          </a:p>
+        </p:txBody>
+      </p:sp>
+    </p:spTree>
+    <p:extLst>
+      <p:ext uri="{BB962C8B-B14F-4D97-AF65-F5344CB8AC3E}">
+        <p14:creationId xmlns:p14="http://schemas.microsoft.com/office/powerpoint/2010/main" val="1915196544"/>
+      </p:ext>
+    </p:extLst>
+  </p:cSld>
+  <p:clrMapOvr>
+    <a:masterClrMapping/>
+  </p:clrMapOvr>
+</p:notes>
+</file>
+
+<file path=ppt/notesSlides/notesSlide6.xml><?xml version="1.0" encoding="utf-8"?>
+<p:notes xmlns:a="http://schemas.openxmlformats.org/drawingml/2006/main" xmlns:r="http://schemas.openxmlformats.org/officeDocument/2006/relationships" xmlns:p="http://schemas.openxmlformats.org/presentationml/2006/main">
+  <p:cSld>
+    <p:spTree>
+      <p:nvGrpSpPr>
+        <p:cNvPr id="1" name="">
+          <a:extLst>
+            <a:ext uri="{FF2B5EF4-FFF2-40B4-BE49-F238E27FC236}">
+              <a16:creationId xmlns:a16="http://schemas.microsoft.com/office/drawing/2014/main" id="{E6E3076F-B399-E750-32E6-26FDD43E8A4B}"/>
+            </a:ext>
+          </a:extLst>
+        </p:cNvPr>
+        <p:cNvGrpSpPr/>
+        <p:nvPr/>
+      </p:nvGrpSpPr>
+      <p:grpSpPr>
+        <a:xfrm>
+          <a:off x="0" y="0"/>
+          <a:ext cx="0" cy="0"/>
+          <a:chOff x="0" y="0"/>
+          <a:chExt cx="0" cy="0"/>
+        </a:xfrm>
+      </p:grpSpPr>
+      <p:sp>
+        <p:nvSpPr>
+          <p:cNvPr id="2" name="Slide Image Placeholder 1">
+            <a:extLst>
+              <a:ext uri="{FF2B5EF4-FFF2-40B4-BE49-F238E27FC236}">
+                <a16:creationId xmlns:a16="http://schemas.microsoft.com/office/drawing/2014/main" id="{39341C61-190B-EA02-16CB-27F99A7BBA2C}"/>
+              </a:ext>
+            </a:extLst>
+          </p:cNvPr>
+          <p:cNvSpPr>
+            <a:spLocks noGrp="1" noRot="1" noChangeAspect="1"/>
+          </p:cNvSpPr>
+          <p:nvPr>
+            <p:ph type="sldImg"/>
+          </p:nvPr>
+        </p:nvSpPr>
+        <p:spPr/>
+        <p:txBody>
+          <a:bodyPr/>
+          <a:lstStyle/>
+          <a:p>
+            <a:endParaRPr lang="en-US"/>
+          </a:p>
+        </p:txBody>
+      </p:sp>
+      <p:sp>
+        <p:nvSpPr>
+          <p:cNvPr id="3" name="Notes Placeholder 2">
+            <a:extLst>
+              <a:ext uri="{FF2B5EF4-FFF2-40B4-BE49-F238E27FC236}">
+                <a16:creationId xmlns:a16="http://schemas.microsoft.com/office/drawing/2014/main" id="{7B8EC9B8-D46C-45A6-EA38-630A298479B1}"/>
+              </a:ext>
+            </a:extLst>
+          </p:cNvPr>
+          <p:cNvSpPr>
+            <a:spLocks noGrp="1"/>
+          </p:cNvSpPr>
+          <p:nvPr>
+            <p:ph type="body" idx="1"/>
+          </p:nvPr>
+        </p:nvSpPr>
+        <p:spPr/>
+        <p:txBody>
+          <a:bodyPr/>
+          <a:lstStyle/>
+          <a:p>
+            <a:pPr marL="0" marR="0" lvl="0" indent="0" algn="l" defTabSz="914400" rtl="0" eaLnBrk="1" fontAlgn="auto" latinLnBrk="0" hangingPunct="1">
+              <a:lnSpc>
+                <a:spcPct val="100000"/>
+              </a:lnSpc>
+              <a:spcBef>
+                <a:spcPts val="0"/>
+              </a:spcBef>
+              <a:spcAft>
+                <a:spcPts val="0"/>
+              </a:spcAft>
+              <a:buClrTx/>
+              <a:buSzTx/>
+              <a:buFontTx/>
+              <a:buNone/>
+              <a:tabLst/>
+              <a:defRPr/>
+            </a:pPr>
+            <a:r>
+              <a:rPr lang="en-US" sz="2400" dirty="0"/>
+              <a:t>Top 4 not counting “other” and NaN</a:t>
+            </a:r>
+          </a:p>
+          <a:p>
+            <a:endParaRPr lang="en-US" dirty="0"/>
+          </a:p>
+        </p:txBody>
+      </p:sp>
+      <p:sp>
+        <p:nvSpPr>
+          <p:cNvPr id="4" name="Slide Number Placeholder 3">
+            <a:extLst>
+              <a:ext uri="{FF2B5EF4-FFF2-40B4-BE49-F238E27FC236}">
+                <a16:creationId xmlns:a16="http://schemas.microsoft.com/office/drawing/2014/main" id="{CC06AF48-692B-7D9D-854D-997E0371576B}"/>
+              </a:ext>
+            </a:extLst>
+          </p:cNvPr>
+          <p:cNvSpPr>
+            <a:spLocks noGrp="1"/>
+          </p:cNvSpPr>
+          <p:nvPr>
+            <p:ph type="sldNum" sz="quarter" idx="5"/>
+          </p:nvPr>
+        </p:nvSpPr>
+        <p:spPr/>
+        <p:txBody>
+          <a:bodyPr/>
+          <a:lstStyle/>
+          <a:p>
+            <a:fld id="{433F17CF-9CB7-1F41-9F3B-9D2A483692EC}" type="slidenum">
+              <a:rPr lang="en-US" smtClean="0"/>
+              <a:t>7</a:t>
+            </a:fld>
+            <a:endParaRPr lang="en-US"/>
+          </a:p>
+        </p:txBody>
+      </p:sp>
+    </p:spTree>
+    <p:extLst>
+      <p:ext uri="{BB962C8B-B14F-4D97-AF65-F5344CB8AC3E}">
+        <p14:creationId xmlns:p14="http://schemas.microsoft.com/office/powerpoint/2010/main" val="4108911654"/>
+      </p:ext>
+    </p:extLst>
+  </p:cSld>
+  <p:clrMapOvr>
+    <a:masterClrMapping/>
+  </p:clrMapOvr>
+</p:notes>
+</file>
+
+<file path=ppt/notesSlides/notesSlide7.xml><?xml version="1.0" encoding="utf-8"?>
+<p:notes xmlns:a="http://schemas.openxmlformats.org/drawingml/2006/main" xmlns:r="http://schemas.openxmlformats.org/officeDocument/2006/relationships" xmlns:p="http://schemas.openxmlformats.org/presentationml/2006/main">
+  <p:cSld>
+    <p:spTree>
+      <p:nvGrpSpPr>
+        <p:cNvPr id="1" name="">
+          <a:extLst>
+            <a:ext uri="{FF2B5EF4-FFF2-40B4-BE49-F238E27FC236}">
+              <a16:creationId xmlns:a16="http://schemas.microsoft.com/office/drawing/2014/main" id="{2F841419-057A-315C-BAA0-7AD719E057F9}"/>
+            </a:ext>
+          </a:extLst>
+        </p:cNvPr>
+        <p:cNvGrpSpPr/>
+        <p:nvPr/>
+      </p:nvGrpSpPr>
+      <p:grpSpPr>
+        <a:xfrm>
+          <a:off x="0" y="0"/>
+          <a:ext cx="0" cy="0"/>
+          <a:chOff x="0" y="0"/>
+          <a:chExt cx="0" cy="0"/>
+        </a:xfrm>
+      </p:grpSpPr>
+      <p:sp>
+        <p:nvSpPr>
+          <p:cNvPr id="2" name="Slide Image Placeholder 1">
+            <a:extLst>
+              <a:ext uri="{FF2B5EF4-FFF2-40B4-BE49-F238E27FC236}">
+                <a16:creationId xmlns:a16="http://schemas.microsoft.com/office/drawing/2014/main" id="{F07AB532-9254-A724-5F7A-FACE3476344F}"/>
+              </a:ext>
+            </a:extLst>
+          </p:cNvPr>
+          <p:cNvSpPr>
+            <a:spLocks noGrp="1" noRot="1" noChangeAspect="1"/>
+          </p:cNvSpPr>
+          <p:nvPr>
+            <p:ph type="sldImg"/>
+          </p:nvPr>
+        </p:nvSpPr>
+        <p:spPr/>
+        <p:txBody>
+          <a:bodyPr/>
+          <a:lstStyle/>
+          <a:p>
+            <a:endParaRPr lang="en-US"/>
+          </a:p>
+        </p:txBody>
+      </p:sp>
+      <p:sp>
+        <p:nvSpPr>
+          <p:cNvPr id="3" name="Notes Placeholder 2">
+            <a:extLst>
+              <a:ext uri="{FF2B5EF4-FFF2-40B4-BE49-F238E27FC236}">
+                <a16:creationId xmlns:a16="http://schemas.microsoft.com/office/drawing/2014/main" id="{F48727C8-CCC9-7DE9-EED4-6B7DAFA6306B}"/>
+              </a:ext>
+            </a:extLst>
+          </p:cNvPr>
+          <p:cNvSpPr>
+            <a:spLocks noGrp="1"/>
+          </p:cNvSpPr>
+          <p:nvPr>
+            <p:ph type="body" idx="1"/>
+          </p:nvPr>
+        </p:nvSpPr>
+        <p:spPr/>
+        <p:txBody>
+          <a:bodyPr/>
+          <a:lstStyle/>
+          <a:p>
+            <a:pPr marL="0" marR="0" lvl="0" indent="0" algn="l" defTabSz="914400" rtl="0" eaLnBrk="1" fontAlgn="auto" latinLnBrk="0" hangingPunct="1">
+              <a:lnSpc>
+                <a:spcPct val="100000"/>
+              </a:lnSpc>
+              <a:spcBef>
+                <a:spcPts val="0"/>
+              </a:spcBef>
+              <a:spcAft>
+                <a:spcPts val="0"/>
+              </a:spcAft>
+              <a:buClrTx/>
+              <a:buSzTx/>
+              <a:buFontTx/>
+              <a:buNone/>
+              <a:tabLst/>
+              <a:defRPr/>
+            </a:pPr>
+            <a:r>
+              <a:rPr lang="en-US" sz="2400" dirty="0"/>
+              <a:t>Note that we need to add 6 or 7 zeros to the numbers.</a:t>
+            </a:r>
+          </a:p>
+          <a:p>
+            <a:pPr marL="0" marR="0" lvl="0" indent="0" algn="l" defTabSz="914400" rtl="0" eaLnBrk="1" fontAlgn="auto" latinLnBrk="0" hangingPunct="1">
+              <a:lnSpc>
+                <a:spcPct val="100000"/>
+              </a:lnSpc>
+              <a:spcBef>
+                <a:spcPts val="0"/>
+              </a:spcBef>
+              <a:spcAft>
+                <a:spcPts val="0"/>
+              </a:spcAft>
+              <a:buClrTx/>
+              <a:buSzTx/>
+              <a:buFontTx/>
+              <a:buNone/>
+              <a:tabLst/>
+              <a:defRPr/>
+            </a:pPr>
+            <a:r>
+              <a:rPr lang="en-US" sz="2400" dirty="0"/>
+              <a:t>Now will zoom in on the bottom– left corner for a better look.</a:t>
+            </a:r>
+          </a:p>
+          <a:p>
+            <a:endParaRPr lang="en-US" dirty="0"/>
+          </a:p>
+        </p:txBody>
+      </p:sp>
+      <p:sp>
+        <p:nvSpPr>
+          <p:cNvPr id="4" name="Slide Number Placeholder 3">
+            <a:extLst>
+              <a:ext uri="{FF2B5EF4-FFF2-40B4-BE49-F238E27FC236}">
+                <a16:creationId xmlns:a16="http://schemas.microsoft.com/office/drawing/2014/main" id="{DC433C83-9FCB-FFF0-DB0E-BF8783D611AF}"/>
+              </a:ext>
+            </a:extLst>
+          </p:cNvPr>
+          <p:cNvSpPr>
+            <a:spLocks noGrp="1"/>
+          </p:cNvSpPr>
+          <p:nvPr>
+            <p:ph type="sldNum" sz="quarter" idx="5"/>
+          </p:nvPr>
+        </p:nvSpPr>
+        <p:spPr/>
+        <p:txBody>
+          <a:bodyPr/>
+          <a:lstStyle/>
+          <a:p>
+            <a:fld id="{433F17CF-9CB7-1F41-9F3B-9D2A483692EC}" type="slidenum">
+              <a:rPr lang="en-US" smtClean="0"/>
+              <a:t>8</a:t>
+            </a:fld>
+            <a:endParaRPr lang="en-US"/>
+          </a:p>
+        </p:txBody>
+      </p:sp>
+    </p:spTree>
+    <p:extLst>
+      <p:ext uri="{BB962C8B-B14F-4D97-AF65-F5344CB8AC3E}">
+        <p14:creationId xmlns:p14="http://schemas.microsoft.com/office/powerpoint/2010/main" val="3219852751"/>
+      </p:ext>
+    </p:extLst>
+  </p:cSld>
+  <p:clrMapOvr>
+    <a:masterClrMapping/>
+  </p:clrMapOvr>
+</p:notes>
+</file>
+
+<file path=ppt/notesSlides/notesSlide8.xml><?xml version="1.0" encoding="utf-8"?>
+<p:notes xmlns:a="http://schemas.openxmlformats.org/drawingml/2006/main" xmlns:r="http://schemas.openxmlformats.org/officeDocument/2006/relationships" xmlns:p="http://schemas.openxmlformats.org/presentationml/2006/main">
+  <p:cSld>
+    <p:spTree>
+      <p:nvGrpSpPr>
+        <p:cNvPr id="1" name="">
+          <a:extLst>
+            <a:ext uri="{FF2B5EF4-FFF2-40B4-BE49-F238E27FC236}">
+              <a16:creationId xmlns:a16="http://schemas.microsoft.com/office/drawing/2014/main" id="{7C8455B3-56E9-30A6-8B3E-7527E27BF12F}"/>
+            </a:ext>
+          </a:extLst>
+        </p:cNvPr>
+        <p:cNvGrpSpPr/>
+        <p:nvPr/>
+      </p:nvGrpSpPr>
+      <p:grpSpPr>
+        <a:xfrm>
+          <a:off x="0" y="0"/>
+          <a:ext cx="0" cy="0"/>
+          <a:chOff x="0" y="0"/>
+          <a:chExt cx="0" cy="0"/>
+        </a:xfrm>
+      </p:grpSpPr>
+      <p:sp>
+        <p:nvSpPr>
+          <p:cNvPr id="2" name="Slide Image Placeholder 1">
+            <a:extLst>
+              <a:ext uri="{FF2B5EF4-FFF2-40B4-BE49-F238E27FC236}">
+                <a16:creationId xmlns:a16="http://schemas.microsoft.com/office/drawing/2014/main" id="{B7A62415-9642-A50F-4A7A-69FCA3A3FAAF}"/>
+              </a:ext>
+            </a:extLst>
+          </p:cNvPr>
+          <p:cNvSpPr>
+            <a:spLocks noGrp="1" noRot="1" noChangeAspect="1"/>
+          </p:cNvSpPr>
+          <p:nvPr>
+            <p:ph type="sldImg"/>
+          </p:nvPr>
+        </p:nvSpPr>
+        <p:spPr/>
+        <p:txBody>
+          <a:bodyPr/>
+          <a:lstStyle/>
+          <a:p>
+            <a:endParaRPr lang="en-US"/>
+          </a:p>
+        </p:txBody>
+      </p:sp>
+      <p:sp>
+        <p:nvSpPr>
+          <p:cNvPr id="3" name="Notes Placeholder 2">
+            <a:extLst>
+              <a:ext uri="{FF2B5EF4-FFF2-40B4-BE49-F238E27FC236}">
+                <a16:creationId xmlns:a16="http://schemas.microsoft.com/office/drawing/2014/main" id="{9764C5C8-6EA7-039A-6306-072AABF89EF4}"/>
+              </a:ext>
+            </a:extLst>
+          </p:cNvPr>
+          <p:cNvSpPr>
+            <a:spLocks noGrp="1"/>
+          </p:cNvSpPr>
+          <p:nvPr>
+            <p:ph type="body" idx="1"/>
+          </p:nvPr>
+        </p:nvSpPr>
+        <p:spPr/>
+        <p:txBody>
+          <a:bodyPr/>
+          <a:lstStyle/>
+          <a:p>
+            <a:r>
+              <a:rPr lang="en-US" sz="2400" dirty="0"/>
+              <a:t>Electricity use by floor area, zoomed – in bottom left corner</a:t>
+            </a:r>
+          </a:p>
+        </p:txBody>
+      </p:sp>
+      <p:sp>
+        <p:nvSpPr>
+          <p:cNvPr id="4" name="Slide Number Placeholder 3">
+            <a:extLst>
+              <a:ext uri="{FF2B5EF4-FFF2-40B4-BE49-F238E27FC236}">
+                <a16:creationId xmlns:a16="http://schemas.microsoft.com/office/drawing/2014/main" id="{F3A75914-7C41-9522-01EE-911D2D39F112}"/>
+              </a:ext>
+            </a:extLst>
+          </p:cNvPr>
+          <p:cNvSpPr>
+            <a:spLocks noGrp="1"/>
+          </p:cNvSpPr>
+          <p:nvPr>
+            <p:ph type="sldNum" sz="quarter" idx="5"/>
+          </p:nvPr>
+        </p:nvSpPr>
+        <p:spPr/>
+        <p:txBody>
+          <a:bodyPr/>
+          <a:lstStyle/>
+          <a:p>
+            <a:fld id="{433F17CF-9CB7-1F41-9F3B-9D2A483692EC}" type="slidenum">
+              <a:rPr lang="en-US" smtClean="0"/>
+              <a:t>9</a:t>
+            </a:fld>
+            <a:endParaRPr lang="en-US"/>
+          </a:p>
+        </p:txBody>
+      </p:sp>
+    </p:spTree>
+    <p:extLst>
+      <p:ext uri="{BB962C8B-B14F-4D97-AF65-F5344CB8AC3E}">
+        <p14:creationId xmlns:p14="http://schemas.microsoft.com/office/powerpoint/2010/main" val="1165965023"/>
+      </p:ext>
+    </p:extLst>
+  </p:cSld>
+  <p:clrMapOvr>
+    <a:masterClrMapping/>
+  </p:clrMapOvr>
+</p:notes>
+</file>
+
+<file path=ppt/notesSlides/notesSlide9.xml><?xml version="1.0" encoding="utf-8"?>
+<p:notes xmlns:a="http://schemas.openxmlformats.org/drawingml/2006/main" xmlns:r="http://schemas.openxmlformats.org/officeDocument/2006/relationships" xmlns:p="http://schemas.openxmlformats.org/presentationml/2006/main">
+  <p:cSld>
+    <p:spTree>
+      <p:nvGrpSpPr>
+        <p:cNvPr id="1" name="">
+          <a:extLst>
+            <a:ext uri="{FF2B5EF4-FFF2-40B4-BE49-F238E27FC236}">
+              <a16:creationId xmlns:a16="http://schemas.microsoft.com/office/drawing/2014/main" id="{41F4D68D-1DA8-5F41-6745-89703CD34B21}"/>
+            </a:ext>
+          </a:extLst>
+        </p:cNvPr>
+        <p:cNvGrpSpPr/>
+        <p:nvPr/>
+      </p:nvGrpSpPr>
+      <p:grpSpPr>
+        <a:xfrm>
+          <a:off x="0" y="0"/>
+          <a:ext cx="0" cy="0"/>
+          <a:chOff x="0" y="0"/>
+          <a:chExt cx="0" cy="0"/>
+        </a:xfrm>
+      </p:grpSpPr>
+      <p:sp>
+        <p:nvSpPr>
+          <p:cNvPr id="2" name="Slide Image Placeholder 1">
+            <a:extLst>
+              <a:ext uri="{FF2B5EF4-FFF2-40B4-BE49-F238E27FC236}">
+                <a16:creationId xmlns:a16="http://schemas.microsoft.com/office/drawing/2014/main" id="{70E4F896-C6B8-F4B8-C975-289106CD7F65}"/>
+              </a:ext>
+            </a:extLst>
+          </p:cNvPr>
+          <p:cNvSpPr>
+            <a:spLocks noGrp="1" noRot="1" noChangeAspect="1"/>
+          </p:cNvSpPr>
+          <p:nvPr>
+            <p:ph type="sldImg"/>
+          </p:nvPr>
+        </p:nvSpPr>
+        <p:spPr/>
+        <p:txBody>
+          <a:bodyPr/>
+          <a:lstStyle/>
+          <a:p>
+            <a:endParaRPr lang="en-US"/>
+          </a:p>
+        </p:txBody>
+      </p:sp>
+      <p:sp>
+        <p:nvSpPr>
+          <p:cNvPr id="3" name="Notes Placeholder 2">
+            <a:extLst>
+              <a:ext uri="{FF2B5EF4-FFF2-40B4-BE49-F238E27FC236}">
+                <a16:creationId xmlns:a16="http://schemas.microsoft.com/office/drawing/2014/main" id="{3368D968-2D3B-644E-2E8C-AB0A673A97D6}"/>
+              </a:ext>
+            </a:extLst>
+          </p:cNvPr>
+          <p:cNvSpPr>
+            <a:spLocks noGrp="1"/>
+          </p:cNvSpPr>
+          <p:nvPr>
+            <p:ph type="body" idx="1"/>
+          </p:nvPr>
+        </p:nvSpPr>
+        <p:spPr/>
+        <p:txBody>
+          <a:bodyPr/>
+          <a:lstStyle/>
+          <a:p>
+            <a:r>
+              <a:rPr lang="en-US" sz="2400" dirty="0"/>
+              <a:t>The British thermal unit (Btu) is a unit of measure of heat.  </a:t>
+            </a:r>
+          </a:p>
+          <a:p>
+            <a:endParaRPr lang="en-US" dirty="0"/>
+          </a:p>
+        </p:txBody>
+      </p:sp>
+      <p:sp>
+        <p:nvSpPr>
+          <p:cNvPr id="4" name="Slide Number Placeholder 3">
+            <a:extLst>
+              <a:ext uri="{FF2B5EF4-FFF2-40B4-BE49-F238E27FC236}">
+                <a16:creationId xmlns:a16="http://schemas.microsoft.com/office/drawing/2014/main" id="{AF7131A2-9F55-3AE3-D0C0-E5B29A651238}"/>
+              </a:ext>
+            </a:extLst>
+          </p:cNvPr>
+          <p:cNvSpPr>
+            <a:spLocks noGrp="1"/>
+          </p:cNvSpPr>
+          <p:nvPr>
+            <p:ph type="sldNum" sz="quarter" idx="5"/>
+          </p:nvPr>
+        </p:nvSpPr>
+        <p:spPr/>
+        <p:txBody>
+          <a:bodyPr/>
+          <a:lstStyle/>
+          <a:p>
+            <a:fld id="{433F17CF-9CB7-1F41-9F3B-9D2A483692EC}" type="slidenum">
+              <a:rPr lang="en-US" smtClean="0"/>
+              <a:t>10</a:t>
+            </a:fld>
+            <a:endParaRPr lang="en-US"/>
+          </a:p>
+        </p:txBody>
+      </p:sp>
+    </p:spTree>
+    <p:extLst>
+      <p:ext uri="{BB962C8B-B14F-4D97-AF65-F5344CB8AC3E}">
+        <p14:creationId xmlns:p14="http://schemas.microsoft.com/office/powerpoint/2010/main" val="4241986356"/>
       </p:ext>
     </p:extLst>
   </p:cSld>
@@ -9807,6 +11158,599 @@
 </p:sld>
 </file>
 
+<file path=ppt/slides/slide10.xml><?xml version="1.0" encoding="utf-8"?>
+<p:sld xmlns:a="http://schemas.openxmlformats.org/drawingml/2006/main" xmlns:r="http://schemas.openxmlformats.org/officeDocument/2006/relationships" xmlns:p="http://schemas.openxmlformats.org/presentationml/2006/main">
+  <p:cSld>
+    <p:spTree>
+      <p:nvGrpSpPr>
+        <p:cNvPr id="1" name="">
+          <a:extLst>
+            <a:ext uri="{FF2B5EF4-FFF2-40B4-BE49-F238E27FC236}">
+              <a16:creationId xmlns:a16="http://schemas.microsoft.com/office/drawing/2014/main" id="{2E5ADF0F-2884-46DE-263D-B4343800DDB0}"/>
+            </a:ext>
+          </a:extLst>
+        </p:cNvPr>
+        <p:cNvGrpSpPr/>
+        <p:nvPr/>
+      </p:nvGrpSpPr>
+      <p:grpSpPr>
+        <a:xfrm>
+          <a:off x="0" y="0"/>
+          <a:ext cx="0" cy="0"/>
+          <a:chOff x="0" y="0"/>
+          <a:chExt cx="0" cy="0"/>
+        </a:xfrm>
+      </p:grpSpPr>
+      <p:sp>
+        <p:nvSpPr>
+          <p:cNvPr id="2" name="Title 1">
+            <a:extLst>
+              <a:ext uri="{FF2B5EF4-FFF2-40B4-BE49-F238E27FC236}">
+                <a16:creationId xmlns:a16="http://schemas.microsoft.com/office/drawing/2014/main" id="{9BB81868-E30C-3692-AE22-8766AE82B42F}"/>
+              </a:ext>
+            </a:extLst>
+          </p:cNvPr>
+          <p:cNvSpPr>
+            <a:spLocks noGrp="1"/>
+          </p:cNvSpPr>
+          <p:nvPr>
+            <p:ph type="title"/>
+          </p:nvPr>
+        </p:nvSpPr>
+        <p:spPr>
+          <a:xfrm>
+            <a:off x="971550" y="562356"/>
+            <a:ext cx="10835640" cy="791926"/>
+          </a:xfrm>
+        </p:spPr>
+        <p:txBody>
+          <a:bodyPr>
+            <a:normAutofit/>
+          </a:bodyPr>
+          <a:lstStyle/>
+          <a:p>
+            <a:r>
+              <a:rPr lang="en-US" sz="3200" dirty="0"/>
+              <a:t>Distribution of Energy Use Intensity</a:t>
+            </a:r>
+          </a:p>
+        </p:txBody>
+      </p:sp>
+      <p:pic>
+        <p:nvPicPr>
+          <p:cNvPr id="5" name="Picture 4">
+            <a:extLst>
+              <a:ext uri="{FF2B5EF4-FFF2-40B4-BE49-F238E27FC236}">
+                <a16:creationId xmlns:a16="http://schemas.microsoft.com/office/drawing/2014/main" id="{A39FCA01-6789-F936-6137-03AB4814D13E}"/>
+              </a:ext>
+            </a:extLst>
+          </p:cNvPr>
+          <p:cNvPicPr>
+            <a:picLocks noChangeAspect="1"/>
+          </p:cNvPicPr>
+          <p:nvPr/>
+        </p:nvPicPr>
+        <p:blipFill>
+          <a:blip r:embed="rId3"/>
+          <a:stretch>
+            <a:fillRect/>
+          </a:stretch>
+        </p:blipFill>
+        <p:spPr>
+          <a:xfrm>
+            <a:off x="648970" y="31797"/>
+            <a:ext cx="10678160" cy="6755570"/>
+          </a:xfrm>
+          <a:prstGeom prst="rect">
+            <a:avLst/>
+          </a:prstGeom>
+        </p:spPr>
+      </p:pic>
+    </p:spTree>
+    <p:extLst>
+      <p:ext uri="{BB962C8B-B14F-4D97-AF65-F5344CB8AC3E}">
+        <p14:creationId xmlns:p14="http://schemas.microsoft.com/office/powerpoint/2010/main" val="1413457445"/>
+      </p:ext>
+    </p:extLst>
+  </p:cSld>
+  <p:clrMapOvr>
+    <a:masterClrMapping/>
+  </p:clrMapOvr>
+</p:sld>
+</file>
+
+<file path=ppt/slides/slide11.xml><?xml version="1.0" encoding="utf-8"?>
+<p:sld xmlns:a="http://schemas.openxmlformats.org/drawingml/2006/main" xmlns:r="http://schemas.openxmlformats.org/officeDocument/2006/relationships" xmlns:p="http://schemas.openxmlformats.org/presentationml/2006/main">
+  <p:cSld>
+    <p:spTree>
+      <p:nvGrpSpPr>
+        <p:cNvPr id="1" name="">
+          <a:extLst>
+            <a:ext uri="{FF2B5EF4-FFF2-40B4-BE49-F238E27FC236}">
+              <a16:creationId xmlns:a16="http://schemas.microsoft.com/office/drawing/2014/main" id="{39BF443E-3501-EA02-B424-7E256FB721AD}"/>
+            </a:ext>
+          </a:extLst>
+        </p:cNvPr>
+        <p:cNvGrpSpPr/>
+        <p:nvPr/>
+      </p:nvGrpSpPr>
+      <p:grpSpPr>
+        <a:xfrm>
+          <a:off x="0" y="0"/>
+          <a:ext cx="0" cy="0"/>
+          <a:chOff x="0" y="0"/>
+          <a:chExt cx="0" cy="0"/>
+        </a:xfrm>
+      </p:grpSpPr>
+      <p:sp>
+        <p:nvSpPr>
+          <p:cNvPr id="2" name="Title 1">
+            <a:extLst>
+              <a:ext uri="{FF2B5EF4-FFF2-40B4-BE49-F238E27FC236}">
+                <a16:creationId xmlns:a16="http://schemas.microsoft.com/office/drawing/2014/main" id="{764B128B-B738-BF3E-1EF8-0C88B7F66462}"/>
+              </a:ext>
+            </a:extLst>
+          </p:cNvPr>
+          <p:cNvSpPr>
+            <a:spLocks noGrp="1"/>
+          </p:cNvSpPr>
+          <p:nvPr>
+            <p:ph type="title"/>
+          </p:nvPr>
+        </p:nvSpPr>
+        <p:spPr>
+          <a:xfrm>
+            <a:off x="182880" y="219456"/>
+            <a:ext cx="10835640" cy="791926"/>
+          </a:xfrm>
+        </p:spPr>
+        <p:txBody>
+          <a:bodyPr>
+            <a:normAutofit/>
+          </a:bodyPr>
+          <a:lstStyle/>
+          <a:p>
+            <a:r>
+              <a:rPr lang="en-US" sz="3200" dirty="0"/>
+              <a:t>Scatter Plot</a:t>
+            </a:r>
+          </a:p>
+        </p:txBody>
+      </p:sp>
+      <p:sp>
+        <p:nvSpPr>
+          <p:cNvPr id="4" name="TextBox 3">
+            <a:extLst>
+              <a:ext uri="{FF2B5EF4-FFF2-40B4-BE49-F238E27FC236}">
+                <a16:creationId xmlns:a16="http://schemas.microsoft.com/office/drawing/2014/main" id="{7EEC0D65-DF7D-A195-1D30-46F0BAA8876A}"/>
+              </a:ext>
+            </a:extLst>
+          </p:cNvPr>
+          <p:cNvSpPr txBox="1"/>
+          <p:nvPr/>
+        </p:nvSpPr>
+        <p:spPr>
+          <a:xfrm>
+            <a:off x="1159626" y="1198072"/>
+            <a:ext cx="10295313" cy="2585323"/>
+          </a:xfrm>
+          <a:prstGeom prst="rect">
+            <a:avLst/>
+          </a:prstGeom>
+          <a:noFill/>
+        </p:spPr>
+        <p:txBody>
+          <a:bodyPr wrap="square" rtlCol="0">
+            <a:spAutoFit/>
+          </a:bodyPr>
+          <a:lstStyle/>
+          <a:p>
+            <a:r>
+              <a:rPr lang="en-US" dirty="0"/>
+              <a:t>Building age vs ENERGY STAR score</a:t>
+            </a:r>
+          </a:p>
+          <a:p>
+            <a:endParaRPr lang="en-US" dirty="0"/>
+          </a:p>
+          <a:p>
+            <a:r>
+              <a:rPr lang="en-US" dirty="0"/>
+              <a:t>Year built vs ENERGY STAR score</a:t>
+            </a:r>
+          </a:p>
+          <a:p>
+            <a:endParaRPr lang="en-US" dirty="0"/>
+          </a:p>
+          <a:p>
+            <a:r>
+              <a:rPr lang="en-US" dirty="0"/>
+              <a:t>Electricity (kWh) vs floor area</a:t>
+            </a:r>
+          </a:p>
+          <a:p>
+            <a:endParaRPr lang="en-US" dirty="0"/>
+          </a:p>
+          <a:p>
+            <a:r>
+              <a:rPr lang="en-US" dirty="0"/>
+              <a:t>Total GHG Emissions (Metric Tons CO2e) vs Reported Property Gross Floor Area area</a:t>
+            </a:r>
+          </a:p>
+          <a:p>
+            <a:endParaRPr lang="en-US" dirty="0"/>
+          </a:p>
+          <a:p>
+            <a:endParaRPr lang="en-US" dirty="0"/>
+          </a:p>
+        </p:txBody>
+      </p:sp>
+    </p:spTree>
+    <p:extLst>
+      <p:ext uri="{BB962C8B-B14F-4D97-AF65-F5344CB8AC3E}">
+        <p14:creationId xmlns:p14="http://schemas.microsoft.com/office/powerpoint/2010/main" val="1826593962"/>
+      </p:ext>
+    </p:extLst>
+  </p:cSld>
+  <p:clrMapOvr>
+    <a:masterClrMapping/>
+  </p:clrMapOvr>
+</p:sld>
+</file>
+
+<file path=ppt/slides/slide12.xml><?xml version="1.0" encoding="utf-8"?>
+<p:sld xmlns:a="http://schemas.openxmlformats.org/drawingml/2006/main" xmlns:r="http://schemas.openxmlformats.org/officeDocument/2006/relationships" xmlns:p="http://schemas.openxmlformats.org/presentationml/2006/main">
+  <p:cSld>
+    <p:spTree>
+      <p:nvGrpSpPr>
+        <p:cNvPr id="1" name=""/>
+        <p:cNvGrpSpPr/>
+        <p:nvPr/>
+      </p:nvGrpSpPr>
+      <p:grpSpPr>
+        <a:xfrm>
+          <a:off x="0" y="0"/>
+          <a:ext cx="0" cy="0"/>
+          <a:chOff x="0" y="0"/>
+          <a:chExt cx="0" cy="0"/>
+        </a:xfrm>
+      </p:grpSpPr>
+      <p:sp>
+        <p:nvSpPr>
+          <p:cNvPr id="2" name="Title 1">
+            <a:extLst>
+              <a:ext uri="{FF2B5EF4-FFF2-40B4-BE49-F238E27FC236}">
+                <a16:creationId xmlns:a16="http://schemas.microsoft.com/office/drawing/2014/main" id="{E1E3B2DF-F9FD-24F2-0A9D-52887C066FE9}"/>
+              </a:ext>
+            </a:extLst>
+          </p:cNvPr>
+          <p:cNvSpPr>
+            <a:spLocks noGrp="1"/>
+          </p:cNvSpPr>
+          <p:nvPr>
+            <p:ph type="title"/>
+          </p:nvPr>
+        </p:nvSpPr>
+        <p:spPr/>
+        <p:txBody>
+          <a:bodyPr/>
+          <a:lstStyle/>
+          <a:p>
+            <a:r>
+              <a:rPr lang="en-US" dirty="0"/>
+              <a:t>Sources and Notes</a:t>
+            </a:r>
+          </a:p>
+        </p:txBody>
+      </p:sp>
+      <p:sp>
+        <p:nvSpPr>
+          <p:cNvPr id="4" name="TextBox 3">
+            <a:extLst>
+              <a:ext uri="{FF2B5EF4-FFF2-40B4-BE49-F238E27FC236}">
+                <a16:creationId xmlns:a16="http://schemas.microsoft.com/office/drawing/2014/main" id="{F2D671FF-C8EA-E68E-64CF-64D869BFE1A0}"/>
+              </a:ext>
+            </a:extLst>
+          </p:cNvPr>
+          <p:cNvSpPr txBox="1"/>
+          <p:nvPr/>
+        </p:nvSpPr>
+        <p:spPr>
+          <a:xfrm>
+            <a:off x="935914" y="1624405"/>
+            <a:ext cx="9854005" cy="6186309"/>
+          </a:xfrm>
+          <a:prstGeom prst="rect">
+            <a:avLst/>
+          </a:prstGeom>
+          <a:noFill/>
+        </p:spPr>
+        <p:txBody>
+          <a:bodyPr wrap="square">
+            <a:spAutoFit/>
+          </a:bodyPr>
+          <a:lstStyle/>
+          <a:p>
+            <a:r>
+              <a:rPr lang="en-US" dirty="0"/>
+              <a:t>2023 Energy Benchmarking All Sites</a:t>
+            </a:r>
+          </a:p>
+          <a:p>
+            <a:r>
+              <a:rPr lang="en-US" dirty="0"/>
+              <a:t>The Energy Benchmarking Law requires the County to make annually reported energy benchmarking information readily available to the public. This dataset reflects data received by the publish date and does not include individually attributable benchmarking data for buildings in Group 5, as CY 2023 was the first year that these buildings were required to report to DEP.</a:t>
+            </a:r>
+          </a:p>
+          <a:p>
+            <a:r>
+              <a:rPr lang="en-US" dirty="0"/>
+              <a:t>September 23, 2025</a:t>
+            </a:r>
+          </a:p>
+          <a:p>
+            <a:r>
+              <a:rPr lang="en-US" dirty="0"/>
+              <a:t>Dataset Owner: Kathy Luh</a:t>
+            </a:r>
+          </a:p>
+          <a:p>
+            <a:r>
+              <a:rPr lang="en-US" dirty="0"/>
+              <a:t>27 columns 1846 rows</a:t>
+            </a:r>
+          </a:p>
+          <a:p>
+            <a:endParaRPr lang="en-US" sz="1800" b="0" i="0" dirty="0">
+              <a:solidFill>
+                <a:srgbClr val="9454C3"/>
+              </a:solidFill>
+              <a:effectLst/>
+              <a:latin typeface="+mn-lt"/>
+              <a:hlinkClick r:id="rId3">
+                <a:extLst>
+                  <a:ext uri="{A12FA001-AC4F-418D-AE19-62706E023703}">
+                    <ahyp:hlinkClr xmlns:ahyp="http://schemas.microsoft.com/office/drawing/2018/hyperlinkcolor" val="tx"/>
+                  </a:ext>
+                </a:extLst>
+              </a:hlinkClick>
+            </a:endParaRPr>
+          </a:p>
+          <a:p>
+            <a:endParaRPr lang="en-US" dirty="0">
+              <a:hlinkClick r:id="rId3">
+                <a:extLst>
+                  <a:ext uri="{A12FA001-AC4F-418D-AE19-62706E023703}">
+                    <ahyp:hlinkClr xmlns:ahyp="http://schemas.microsoft.com/office/drawing/2018/hyperlinkcolor" val="tx"/>
+                  </a:ext>
+                </a:extLst>
+              </a:hlinkClick>
+            </a:endParaRPr>
+          </a:p>
+          <a:p>
+            <a:r>
+              <a:rPr lang="en-US" dirty="0">
+                <a:hlinkClick r:id="rId3">
+                  <a:extLst>
+                    <a:ext uri="{A12FA001-AC4F-418D-AE19-62706E023703}">
+                      <ahyp:hlinkClr xmlns:ahyp="http://schemas.microsoft.com/office/drawing/2018/hyperlinkcolor" val="tx"/>
+                    </a:ext>
+                  </a:extLst>
+                </a:hlinkClick>
+              </a:rPr>
+              <a:t>https://data.montgomerycountymd.gov/Environment/2023-Energy-Benchmarking-All-Sites/ensr-8pr2/about_data</a:t>
+            </a:r>
+            <a:endParaRPr lang="en-US" dirty="0"/>
+          </a:p>
+          <a:p>
+            <a:endParaRPr lang="en-US" dirty="0"/>
+          </a:p>
+          <a:p>
+            <a:r>
+              <a:rPr lang="en-US" dirty="0">
+                <a:hlinkClick r:id="rId4">
+                  <a:extLst>
+                    <a:ext uri="{A12FA001-AC4F-418D-AE19-62706E023703}">
+                      <ahyp:hlinkClr xmlns:ahyp="http://schemas.microsoft.com/office/drawing/2018/hyperlinkcolor" val="tx"/>
+                    </a:ext>
+                  </a:extLst>
+                </a:hlinkClick>
+              </a:rPr>
+              <a:t>https://www.energystar.gov/buildings/benchmark</a:t>
+            </a:r>
+            <a:endParaRPr lang="en-US" dirty="0"/>
+          </a:p>
+          <a:p>
+            <a:endParaRPr lang="en-US" sz="1800" b="0" i="0" dirty="0">
+              <a:effectLst/>
+              <a:latin typeface="+mn-lt"/>
+            </a:endParaRPr>
+          </a:p>
+          <a:p>
+            <a:r>
+              <a:rPr lang="en-US" u="sng" dirty="0"/>
+              <a:t>https://www.energystar.gov/buildings/about-us</a:t>
+            </a:r>
+            <a:endParaRPr lang="en-US" sz="1800" b="0" i="0" u="sng" dirty="0">
+              <a:effectLst/>
+              <a:latin typeface="+mn-lt"/>
+            </a:endParaRPr>
+          </a:p>
+          <a:p>
+            <a:endParaRPr lang="en-US" dirty="0"/>
+          </a:p>
+          <a:p>
+            <a:endParaRPr lang="en-US" dirty="0"/>
+          </a:p>
+          <a:p>
+            <a:endParaRPr lang="en-US" dirty="0"/>
+          </a:p>
+          <a:p>
+            <a:endParaRPr lang="en-US" dirty="0"/>
+          </a:p>
+          <a:p>
+            <a:endParaRPr lang="en-US" dirty="0"/>
+          </a:p>
+        </p:txBody>
+      </p:sp>
+    </p:spTree>
+    <p:extLst>
+      <p:ext uri="{BB962C8B-B14F-4D97-AF65-F5344CB8AC3E}">
+        <p14:creationId xmlns:p14="http://schemas.microsoft.com/office/powerpoint/2010/main" val="708741681"/>
+      </p:ext>
+    </p:extLst>
+  </p:cSld>
+  <p:clrMapOvr>
+    <a:masterClrMapping/>
+  </p:clrMapOvr>
+</p:sld>
+</file>
+
+<file path=ppt/slides/slide13.xml><?xml version="1.0" encoding="utf-8"?>
+<p:sld xmlns:a="http://schemas.openxmlformats.org/drawingml/2006/main" xmlns:r="http://schemas.openxmlformats.org/officeDocument/2006/relationships" xmlns:p="http://schemas.openxmlformats.org/presentationml/2006/main">
+  <p:cSld>
+    <p:spTree>
+      <p:nvGrpSpPr>
+        <p:cNvPr id="1" name="">
+          <a:extLst>
+            <a:ext uri="{FF2B5EF4-FFF2-40B4-BE49-F238E27FC236}">
+              <a16:creationId xmlns:a16="http://schemas.microsoft.com/office/drawing/2014/main" id="{C8909556-D094-88ED-99BD-A18828B5FF94}"/>
+            </a:ext>
+          </a:extLst>
+        </p:cNvPr>
+        <p:cNvGrpSpPr/>
+        <p:nvPr/>
+      </p:nvGrpSpPr>
+      <p:grpSpPr>
+        <a:xfrm>
+          <a:off x="0" y="0"/>
+          <a:ext cx="0" cy="0"/>
+          <a:chOff x="0" y="0"/>
+          <a:chExt cx="0" cy="0"/>
+        </a:xfrm>
+      </p:grpSpPr>
+      <p:sp>
+        <p:nvSpPr>
+          <p:cNvPr id="2" name="Title 1">
+            <a:extLst>
+              <a:ext uri="{FF2B5EF4-FFF2-40B4-BE49-F238E27FC236}">
+                <a16:creationId xmlns:a16="http://schemas.microsoft.com/office/drawing/2014/main" id="{3E25A48D-0768-A3B8-D12B-682FA04112C5}"/>
+              </a:ext>
+            </a:extLst>
+          </p:cNvPr>
+          <p:cNvSpPr>
+            <a:spLocks noGrp="1"/>
+          </p:cNvSpPr>
+          <p:nvPr>
+            <p:ph type="title"/>
+          </p:nvPr>
+        </p:nvSpPr>
+        <p:spPr>
+          <a:xfrm>
+            <a:off x="182880" y="219456"/>
+            <a:ext cx="10835640" cy="791926"/>
+          </a:xfrm>
+        </p:spPr>
+        <p:txBody>
+          <a:bodyPr>
+            <a:normAutofit/>
+          </a:bodyPr>
+          <a:lstStyle/>
+          <a:p>
+            <a:r>
+              <a:rPr lang="en-US" sz="3200" dirty="0"/>
+              <a:t>Notes</a:t>
+            </a:r>
+          </a:p>
+        </p:txBody>
+      </p:sp>
+      <p:sp>
+        <p:nvSpPr>
+          <p:cNvPr id="4" name="TextBox 3">
+            <a:extLst>
+              <a:ext uri="{FF2B5EF4-FFF2-40B4-BE49-F238E27FC236}">
+                <a16:creationId xmlns:a16="http://schemas.microsoft.com/office/drawing/2014/main" id="{4C5F2846-C481-8E79-2AE9-AAD75326287D}"/>
+              </a:ext>
+            </a:extLst>
+          </p:cNvPr>
+          <p:cNvSpPr txBox="1"/>
+          <p:nvPr/>
+        </p:nvSpPr>
+        <p:spPr>
+          <a:xfrm>
+            <a:off x="1159626" y="1198072"/>
+            <a:ext cx="10295313" cy="3693319"/>
+          </a:xfrm>
+          <a:prstGeom prst="rect">
+            <a:avLst/>
+          </a:prstGeom>
+          <a:noFill/>
+        </p:spPr>
+        <p:txBody>
+          <a:bodyPr wrap="square" rtlCol="0">
+            <a:spAutoFit/>
+          </a:bodyPr>
+          <a:lstStyle/>
+          <a:p>
+            <a:r>
+              <a:rPr lang="en-US" sz="2400" dirty="0"/>
+              <a:t>Btu:  the British thermal unit (Btu) is a unit of measure of heat.  </a:t>
+            </a:r>
+          </a:p>
+          <a:p>
+            <a:r>
+              <a:rPr lang="en-US" sz="2400" dirty="0"/>
+              <a:t>It’s the amount of heat required to raise the temperature of one </a:t>
+            </a:r>
+          </a:p>
+          <a:p>
+            <a:r>
+              <a:rPr lang="en-US" sz="2400" dirty="0"/>
+              <a:t>pound of water by one degree Fahrenheit.</a:t>
+            </a:r>
+          </a:p>
+          <a:p>
+            <a:r>
+              <a:rPr lang="en-US" sz="2400" dirty="0"/>
+              <a:t>One Btu equals about 1,055 joules. </a:t>
+            </a:r>
+          </a:p>
+          <a:p>
+            <a:endParaRPr lang="en-US" sz="2400" dirty="0"/>
+          </a:p>
+          <a:p>
+            <a:endParaRPr lang="en-US" sz="2400" dirty="0"/>
+          </a:p>
+          <a:p>
+            <a:pPr lvl="0">
+              <a:defRPr/>
+            </a:pPr>
+            <a:r>
+              <a:rPr lang="en-US" sz="2400" dirty="0"/>
+              <a:t>Energy Star: 1–100 score, which rates energy performance in comparison to similar buildings across the country</a:t>
+            </a:r>
+          </a:p>
+          <a:p>
+            <a:endParaRPr lang="en-US" sz="2400" dirty="0"/>
+          </a:p>
+          <a:p>
+            <a:endParaRPr lang="en-US" dirty="0"/>
+          </a:p>
+        </p:txBody>
+      </p:sp>
+    </p:spTree>
+    <p:extLst>
+      <p:ext uri="{BB962C8B-B14F-4D97-AF65-F5344CB8AC3E}">
+        <p14:creationId xmlns:p14="http://schemas.microsoft.com/office/powerpoint/2010/main" val="3112365671"/>
+      </p:ext>
+    </p:extLst>
+  </p:cSld>
+  <p:clrMapOvr>
+    <a:masterClrMapping/>
+  </p:clrMapOvr>
+</p:sld>
+</file>
+
 <file path=ppt/slides/slide2.xml><?xml version="1.0" encoding="utf-8"?>
 <p:sld xmlns:a="http://schemas.openxmlformats.org/drawingml/2006/main" xmlns:r="http://schemas.openxmlformats.org/officeDocument/2006/relationships" xmlns:p="http://schemas.openxmlformats.org/presentationml/2006/main">
   <p:cSld>
@@ -9842,11 +11786,13 @@
         </p:nvSpPr>
         <p:spPr/>
         <p:txBody>
-          <a:bodyPr/>
-          <a:lstStyle/>
-          <a:p>
-            <a:r>
-              <a:rPr lang="en-US" dirty="0"/>
+          <a:bodyPr>
+            <a:normAutofit/>
+          </a:bodyPr>
+          <a:lstStyle/>
+          <a:p>
+            <a:r>
+              <a:rPr lang="en-US" sz="3200" dirty="0"/>
               <a:t>Source Dataset</a:t>
             </a:r>
           </a:p>
@@ -9866,8 +11812,8 @@
         </p:nvSpPr>
         <p:spPr>
           <a:xfrm>
-            <a:off x="1021976" y="1188720"/>
-            <a:ext cx="8127403" cy="1754326"/>
+            <a:off x="1285212" y="2283229"/>
+            <a:ext cx="8127403" cy="2646878"/>
           </a:xfrm>
           <a:prstGeom prst="rect">
             <a:avLst/>
@@ -9881,23 +11827,32 @@
           <a:lstStyle/>
           <a:p>
             <a:r>
-              <a:rPr lang="en-US" sz="1800" dirty="0"/>
+              <a:rPr lang="en-US" sz="2800" dirty="0"/>
               <a:t>2023 Energy Benchmarking All Sites</a:t>
             </a:r>
           </a:p>
           <a:p>
-            <a:endParaRPr lang="en-US" dirty="0"/>
-          </a:p>
-          <a:p>
-            <a:endParaRPr lang="en-US" sz="1800" dirty="0"/>
-          </a:p>
-          <a:p>
-            <a:r>
-              <a:rPr lang="en-US" dirty="0">
-                <a:hlinkClick r:id="rId2"/>
+            <a:endParaRPr lang="en-US" sz="2800" dirty="0"/>
+          </a:p>
+          <a:p>
+            <a:endParaRPr lang="en-US" sz="2800" dirty="0"/>
+          </a:p>
+          <a:p>
+            <a:r>
+              <a:rPr lang="en-US" sz="2800" u="sng" dirty="0">
+                <a:hlinkClick r:id="rId2">
+                  <a:extLst>
+                    <a:ext uri="{A12FA001-AC4F-418D-AE19-62706E023703}">
+                      <ahyp:hlinkClr xmlns:ahyp="http://schemas.microsoft.com/office/drawing/2018/hyperlinkcolor" val="tx"/>
+                    </a:ext>
+                  </a:extLst>
+                </a:hlinkClick>
               </a:rPr>
               <a:t>https://data.montgomerycountymd.gov</a:t>
             </a:r>
+            <a:endParaRPr lang="en-US" sz="2800" u="sng" dirty="0"/>
+          </a:p>
+          <a:p>
             <a:endParaRPr lang="en-US" dirty="0"/>
           </a:p>
           <a:p>
@@ -9956,8 +11911,8 @@
         </p:nvSpPr>
         <p:spPr>
           <a:xfrm>
-            <a:off x="1014153" y="953746"/>
-            <a:ext cx="7063047" cy="3729090"/>
+            <a:off x="3140481" y="2337815"/>
+            <a:ext cx="6415000" cy="1091185"/>
           </a:xfrm>
         </p:spPr>
         <p:txBody>
@@ -9967,37 +11922,21 @@
           <a:lstStyle/>
           <a:p>
             <a:r>
-              <a:rPr lang="en-US" dirty="0"/>
+              <a:rPr lang="en-US" sz="4000" dirty="0"/>
               <a:t>What is Benchmarking?</a:t>
             </a:r>
             <a:br>
-              <a:rPr lang="en-US" dirty="0"/>
+              <a:rPr lang="en-US" sz="3600" dirty="0"/>
             </a:br>
             <a:br>
-              <a:rPr lang="en-US" dirty="0"/>
+              <a:rPr lang="en-US" sz="3600" dirty="0"/>
             </a:br>
             <a:br>
-              <a:rPr lang="en-US" dirty="0"/>
+              <a:rPr lang="en-US" sz="3600" dirty="0"/>
             </a:br>
             <a:br>
-              <a:rPr lang="en-US" dirty="0"/>
+              <a:rPr lang="en-US" sz="3600" dirty="0"/>
             </a:br>
-            <a:br>
-              <a:rPr lang="en-US" dirty="0"/>
-            </a:br>
-            <a:br>
-              <a:rPr lang="en-US" dirty="0"/>
-            </a:br>
-            <a:br>
-              <a:rPr lang="en-US" dirty="0"/>
-            </a:br>
-            <a:br>
-              <a:rPr lang="en-US" dirty="0"/>
-            </a:br>
-            <a:r>
-              <a:rPr lang="en-US" dirty="0"/>
-              <a:t>Energy Star Score</a:t>
-            </a:r>
             <a:br>
               <a:rPr lang="en-US" dirty="0"/>
             </a:br>
@@ -10052,7 +11991,7 @@
           <p:cNvPr id="2" name="Title 1">
             <a:extLst>
               <a:ext uri="{FF2B5EF4-FFF2-40B4-BE49-F238E27FC236}">
-                <a16:creationId xmlns:a16="http://schemas.microsoft.com/office/drawing/2014/main" id="{E1E3B2DF-F9FD-24F2-0A9D-52887C066FE9}"/>
+                <a16:creationId xmlns:a16="http://schemas.microsoft.com/office/drawing/2014/main" id="{4FCB3986-78F3-ABAC-7921-CFEC2952661B}"/>
               </a:ext>
             </a:extLst>
           </p:cNvPr>
@@ -10063,14 +12002,21 @@
             <p:ph type="title"/>
           </p:nvPr>
         </p:nvSpPr>
-        <p:spPr/>
-        <p:txBody>
-          <a:bodyPr/>
-          <a:lstStyle/>
-          <a:p>
-            <a:r>
-              <a:rPr lang="en-US" dirty="0"/>
-              <a:t>Sources and Notes</a:t>
+        <p:spPr>
+          <a:xfrm>
+            <a:off x="182880" y="219456"/>
+            <a:ext cx="10835640" cy="791926"/>
+          </a:xfrm>
+        </p:spPr>
+        <p:txBody>
+          <a:bodyPr>
+            <a:normAutofit/>
+          </a:bodyPr>
+          <a:lstStyle/>
+          <a:p>
+            <a:r>
+              <a:rPr lang="en-US" sz="3200" dirty="0"/>
+              <a:t>Exploratory Analysis </a:t>
             </a:r>
           </a:p>
         </p:txBody>
@@ -10080,7 +12026,7 @@
           <p:cNvPr id="4" name="TextBox 3">
             <a:extLst>
               <a:ext uri="{FF2B5EF4-FFF2-40B4-BE49-F238E27FC236}">
-                <a16:creationId xmlns:a16="http://schemas.microsoft.com/office/drawing/2014/main" id="{F2D671FF-C8EA-E68E-64CF-64D869BFE1A0}"/>
+                <a16:creationId xmlns:a16="http://schemas.microsoft.com/office/drawing/2014/main" id="{9F5E170C-F976-2954-22A2-6DD6024FD83B}"/>
               </a:ext>
             </a:extLst>
           </p:cNvPr>
@@ -10089,8 +12035,8 @@
         </p:nvSpPr>
         <p:spPr>
           <a:xfrm>
-            <a:off x="935914" y="1624405"/>
-            <a:ext cx="9854005" cy="6186309"/>
+            <a:off x="1512101" y="1011382"/>
+            <a:ext cx="10295313" cy="5152308"/>
           </a:xfrm>
           <a:prstGeom prst="rect">
             <a:avLst/>
@@ -10098,137 +12044,604 @@
           <a:noFill/>
         </p:spPr>
         <p:txBody>
-          <a:bodyPr wrap="square">
+          <a:bodyPr wrap="square" rtlCol="0">
             <a:spAutoFit/>
           </a:bodyPr>
           <a:lstStyle/>
           <a:p>
-            <a:r>
-              <a:rPr lang="en-US" dirty="0"/>
-              <a:t>2023 Energy Benchmarking All Sites</a:t>
-            </a:r>
-          </a:p>
-          <a:p>
-            <a:r>
-              <a:rPr lang="en-US" dirty="0"/>
-              <a:t>The Energy Benchmarking Law requires the County to make annually reported energy benchmarking information readily available to the public. This dataset reflects data received by the publish date and does not include individually attributable benchmarking data for buildings in Group 5, as CY 2023 was the first year that these buildings were required to report to DEP.</a:t>
-            </a:r>
-          </a:p>
-          <a:p>
-            <a:r>
-              <a:rPr lang="en-US" dirty="0"/>
-              <a:t>September 23, 2025</a:t>
-            </a:r>
-          </a:p>
-          <a:p>
-            <a:r>
-              <a:rPr lang="en-US" dirty="0"/>
-              <a:t>Dataset Owner: Kathy Luh</a:t>
-            </a:r>
-          </a:p>
-          <a:p>
-            <a:r>
-              <a:rPr lang="en-US" dirty="0"/>
-              <a:t>27 columns 1846 rows</a:t>
-            </a:r>
-          </a:p>
-          <a:p>
-            <a:endParaRPr lang="en-US" sz="1800" b="0" i="0" dirty="0">
-              <a:solidFill>
-                <a:srgbClr val="9454C3"/>
-              </a:solidFill>
-              <a:effectLst/>
-              <a:latin typeface="+mn-lt"/>
-              <a:hlinkClick r:id="rId3">
-                <a:extLst>
-                  <a:ext uri="{A12FA001-AC4F-418D-AE19-62706E023703}">
-                    <ahyp:hlinkClr xmlns:ahyp="http://schemas.microsoft.com/office/drawing/2018/hyperlinkcolor" val="tx"/>
-                  </a:ext>
-                </a:extLst>
-              </a:hlinkClick>
-            </a:endParaRPr>
-          </a:p>
-          <a:p>
-            <a:endParaRPr lang="en-US" dirty="0">
-              <a:hlinkClick r:id="rId3">
-                <a:extLst>
-                  <a:ext uri="{A12FA001-AC4F-418D-AE19-62706E023703}">
-                    <ahyp:hlinkClr xmlns:ahyp="http://schemas.microsoft.com/office/drawing/2018/hyperlinkcolor" val="tx"/>
-                  </a:ext>
-                </a:extLst>
-              </a:hlinkClick>
-            </a:endParaRPr>
-          </a:p>
-          <a:p>
-            <a:r>
-              <a:rPr lang="en-US" dirty="0">
-                <a:hlinkClick r:id="rId3">
-                  <a:extLst>
-                    <a:ext uri="{A12FA001-AC4F-418D-AE19-62706E023703}">
-                      <ahyp:hlinkClr xmlns:ahyp="http://schemas.microsoft.com/office/drawing/2018/hyperlinkcolor" val="tx"/>
-                    </a:ext>
-                  </a:extLst>
-                </a:hlinkClick>
-              </a:rPr>
-              <a:t>https://data.montgomerycountymd.gov/Environment/2023-Energy-Benchmarking-All-Sites/ensr-8pr2/about_data</a:t>
-            </a:r>
-            <a:endParaRPr lang="en-US" dirty="0"/>
-          </a:p>
-          <a:p>
-            <a:endParaRPr lang="en-US" dirty="0"/>
-          </a:p>
-          <a:p>
-            <a:r>
-              <a:rPr lang="en-US" dirty="0">
-                <a:hlinkClick r:id="rId4">
-                  <a:extLst>
-                    <a:ext uri="{A12FA001-AC4F-418D-AE19-62706E023703}">
-                      <ahyp:hlinkClr xmlns:ahyp="http://schemas.microsoft.com/office/drawing/2018/hyperlinkcolor" val="tx"/>
-                    </a:ext>
-                  </a:extLst>
-                </a:hlinkClick>
-              </a:rPr>
-              <a:t>https://www.energystar.gov/buildings/benchmark</a:t>
-            </a:r>
-            <a:endParaRPr lang="en-US" dirty="0"/>
-          </a:p>
-          <a:p>
-            <a:endParaRPr lang="en-US" sz="1800" b="0" i="0" dirty="0">
-              <a:effectLst/>
-              <a:latin typeface="+mn-lt"/>
-            </a:endParaRPr>
-          </a:p>
-          <a:p>
-            <a:r>
-              <a:rPr lang="en-US" u="sng" dirty="0"/>
-              <a:t>https://www.energystar.gov/buildings/about-us</a:t>
-            </a:r>
-            <a:endParaRPr lang="en-US" sz="1800" b="0" i="0" u="sng" dirty="0">
-              <a:effectLst/>
-              <a:latin typeface="+mn-lt"/>
-            </a:endParaRPr>
-          </a:p>
-          <a:p>
-            <a:endParaRPr lang="en-US" dirty="0"/>
-          </a:p>
-          <a:p>
-            <a:endParaRPr lang="en-US" dirty="0"/>
-          </a:p>
-          <a:p>
-            <a:endParaRPr lang="en-US" dirty="0"/>
-          </a:p>
-          <a:p>
-            <a:endParaRPr lang="en-US" dirty="0"/>
-          </a:p>
-          <a:p>
-            <a:endParaRPr lang="en-US" dirty="0"/>
+            <a:pPr>
+              <a:lnSpc>
+                <a:spcPct val="200000"/>
+              </a:lnSpc>
+            </a:pPr>
+            <a:r>
+              <a:rPr lang="en-US" sz="2400" dirty="0"/>
+              <a:t>1846 rows, 27 columns </a:t>
+            </a:r>
+          </a:p>
+          <a:p>
+            <a:pPr>
+              <a:lnSpc>
+                <a:spcPct val="200000"/>
+              </a:lnSpc>
+            </a:pPr>
+            <a:r>
+              <a:rPr lang="en-US" sz="2400" dirty="0"/>
+              <a:t>25 duplicate entries</a:t>
+            </a:r>
+          </a:p>
+          <a:p>
+            <a:pPr>
+              <a:lnSpc>
+                <a:spcPct val="200000"/>
+              </a:lnSpc>
+            </a:pPr>
+            <a:r>
+              <a:rPr lang="en-US" sz="2400" dirty="0"/>
+              <a:t>1821 remaining</a:t>
+            </a:r>
+          </a:p>
+          <a:p>
+            <a:pPr>
+              <a:lnSpc>
+                <a:spcPct val="200000"/>
+              </a:lnSpc>
+            </a:pPr>
+            <a:r>
+              <a:rPr lang="en-US" sz="2400" dirty="0"/>
+              <a:t>Missing ID numbers and addresses</a:t>
+            </a:r>
+          </a:p>
+          <a:p>
+            <a:pPr>
+              <a:lnSpc>
+                <a:spcPct val="200000"/>
+              </a:lnSpc>
+            </a:pPr>
+            <a:r>
+              <a:rPr lang="en-US" sz="2400" dirty="0"/>
+              <a:t>Electricity (kWh) had the most unique entries:  	1716</a:t>
+            </a:r>
+          </a:p>
+          <a:p>
+            <a:pPr>
+              <a:lnSpc>
+                <a:spcPct val="200000"/>
+              </a:lnSpc>
+            </a:pPr>
+            <a:r>
+              <a:rPr lang="en-US" sz="2400" dirty="0"/>
+              <a:t>Reported Property Gross Floor Area unique: 		1672</a:t>
+            </a:r>
+          </a:p>
+          <a:p>
+            <a:pPr>
+              <a:lnSpc>
+                <a:spcPct val="200000"/>
+              </a:lnSpc>
+            </a:pPr>
+            <a:r>
+              <a:rPr lang="en-US" sz="2400" dirty="0"/>
+              <a:t>Total GHG Emissions (Metric Tons CO2e) unique:  	1619</a:t>
+            </a:r>
           </a:p>
         </p:txBody>
       </p:sp>
     </p:spTree>
     <p:extLst>
       <p:ext uri="{BB962C8B-B14F-4D97-AF65-F5344CB8AC3E}">
-        <p14:creationId xmlns:p14="http://schemas.microsoft.com/office/powerpoint/2010/main" val="708741681"/>
+        <p14:creationId xmlns:p14="http://schemas.microsoft.com/office/powerpoint/2010/main" val="2843265121"/>
+      </p:ext>
+    </p:extLst>
+  </p:cSld>
+  <p:clrMapOvr>
+    <a:masterClrMapping/>
+  </p:clrMapOvr>
+</p:sld>
+</file>
+
+<file path=ppt/slides/slide5.xml><?xml version="1.0" encoding="utf-8"?>
+<p:sld xmlns:a="http://schemas.openxmlformats.org/drawingml/2006/main" xmlns:r="http://schemas.openxmlformats.org/officeDocument/2006/relationships" xmlns:p="http://schemas.openxmlformats.org/presentationml/2006/main">
+  <p:cSld>
+    <p:spTree>
+      <p:nvGrpSpPr>
+        <p:cNvPr id="1" name="">
+          <a:extLst>
+            <a:ext uri="{FF2B5EF4-FFF2-40B4-BE49-F238E27FC236}">
+              <a16:creationId xmlns:a16="http://schemas.microsoft.com/office/drawing/2014/main" id="{E8ACE1E1-1798-58AE-70B0-42B792392228}"/>
+            </a:ext>
+          </a:extLst>
+        </p:cNvPr>
+        <p:cNvGrpSpPr/>
+        <p:nvPr/>
+      </p:nvGrpSpPr>
+      <p:grpSpPr>
+        <a:xfrm>
+          <a:off x="0" y="0"/>
+          <a:ext cx="0" cy="0"/>
+          <a:chOff x="0" y="0"/>
+          <a:chExt cx="0" cy="0"/>
+        </a:xfrm>
+      </p:grpSpPr>
+      <p:sp>
+        <p:nvSpPr>
+          <p:cNvPr id="8" name="Title 7">
+            <a:extLst>
+              <a:ext uri="{FF2B5EF4-FFF2-40B4-BE49-F238E27FC236}">
+                <a16:creationId xmlns:a16="http://schemas.microsoft.com/office/drawing/2014/main" id="{04FA671C-49F3-7EDE-329D-407806844210}"/>
+              </a:ext>
+            </a:extLst>
+          </p:cNvPr>
+          <p:cNvSpPr>
+            <a:spLocks noGrp="1"/>
+          </p:cNvSpPr>
+          <p:nvPr>
+            <p:ph type="title"/>
+          </p:nvPr>
+        </p:nvSpPr>
+        <p:spPr/>
+        <p:txBody>
+          <a:bodyPr/>
+          <a:lstStyle/>
+          <a:p>
+            <a:r>
+              <a:rPr lang="en-US" dirty="0"/>
+              <a:t>					</a:t>
+            </a:r>
+            <a:br>
+              <a:rPr lang="en-US" dirty="0"/>
+            </a:br>
+            <a:r>
+              <a:rPr lang="en-US" dirty="0"/>
+              <a:t>							Histogram</a:t>
+            </a:r>
+          </a:p>
+        </p:txBody>
+      </p:sp>
+      <p:pic>
+        <p:nvPicPr>
+          <p:cNvPr id="3" name="Picture 2">
+            <a:extLst>
+              <a:ext uri="{FF2B5EF4-FFF2-40B4-BE49-F238E27FC236}">
+                <a16:creationId xmlns:a16="http://schemas.microsoft.com/office/drawing/2014/main" id="{960698C5-8852-78C1-170F-56B08C45B10A}"/>
+              </a:ext>
+            </a:extLst>
+          </p:cNvPr>
+          <p:cNvPicPr>
+            <a:picLocks noChangeAspect="1"/>
+          </p:cNvPicPr>
+          <p:nvPr/>
+        </p:nvPicPr>
+        <p:blipFill>
+          <a:blip r:embed="rId3"/>
+          <a:stretch>
+            <a:fillRect/>
+          </a:stretch>
+        </p:blipFill>
+        <p:spPr>
+          <a:xfrm>
+            <a:off x="568346" y="137252"/>
+            <a:ext cx="11055308" cy="6583496"/>
+          </a:xfrm>
+          <a:prstGeom prst="rect">
+            <a:avLst/>
+          </a:prstGeom>
+        </p:spPr>
+      </p:pic>
+    </p:spTree>
+    <p:extLst>
+      <p:ext uri="{BB962C8B-B14F-4D97-AF65-F5344CB8AC3E}">
+        <p14:creationId xmlns:p14="http://schemas.microsoft.com/office/powerpoint/2010/main" val="1604359559"/>
+      </p:ext>
+    </p:extLst>
+  </p:cSld>
+  <p:clrMapOvr>
+    <a:masterClrMapping/>
+  </p:clrMapOvr>
+</p:sld>
+</file>
+
+<file path=ppt/slides/slide6.xml><?xml version="1.0" encoding="utf-8"?>
+<p:sld xmlns:a="http://schemas.openxmlformats.org/drawingml/2006/main" xmlns:r="http://schemas.openxmlformats.org/officeDocument/2006/relationships" xmlns:p="http://schemas.openxmlformats.org/presentationml/2006/main">
+  <p:cSld>
+    <p:spTree>
+      <p:nvGrpSpPr>
+        <p:cNvPr id="1" name="">
+          <a:extLst>
+            <a:ext uri="{FF2B5EF4-FFF2-40B4-BE49-F238E27FC236}">
+              <a16:creationId xmlns:a16="http://schemas.microsoft.com/office/drawing/2014/main" id="{5CE45521-1203-AF03-096A-156FCB2952DC}"/>
+            </a:ext>
+          </a:extLst>
+        </p:cNvPr>
+        <p:cNvGrpSpPr/>
+        <p:nvPr/>
+      </p:nvGrpSpPr>
+      <p:grpSpPr>
+        <a:xfrm>
+          <a:off x="0" y="0"/>
+          <a:ext cx="0" cy="0"/>
+          <a:chOff x="0" y="0"/>
+          <a:chExt cx="0" cy="0"/>
+        </a:xfrm>
+      </p:grpSpPr>
+      <p:sp>
+        <p:nvSpPr>
+          <p:cNvPr id="2" name="Title 1">
+            <a:extLst>
+              <a:ext uri="{FF2B5EF4-FFF2-40B4-BE49-F238E27FC236}">
+                <a16:creationId xmlns:a16="http://schemas.microsoft.com/office/drawing/2014/main" id="{ACD03AE2-C871-FE83-C7BD-96FE5463E081}"/>
+              </a:ext>
+            </a:extLst>
+          </p:cNvPr>
+          <p:cNvSpPr>
+            <a:spLocks noGrp="1"/>
+          </p:cNvSpPr>
+          <p:nvPr>
+            <p:ph type="title"/>
+          </p:nvPr>
+        </p:nvSpPr>
+        <p:spPr>
+          <a:xfrm>
+            <a:off x="971550" y="562356"/>
+            <a:ext cx="10835640" cy="791926"/>
+          </a:xfrm>
+        </p:spPr>
+        <p:txBody>
+          <a:bodyPr>
+            <a:normAutofit/>
+          </a:bodyPr>
+          <a:lstStyle/>
+          <a:p>
+            <a:r>
+              <a:rPr lang="en-US" sz="3200" dirty="0"/>
+              <a:t>Energy Star Scores</a:t>
+            </a:r>
+          </a:p>
+        </p:txBody>
+      </p:sp>
+      <p:pic>
+        <p:nvPicPr>
+          <p:cNvPr id="4" name="Picture 3">
+            <a:extLst>
+              <a:ext uri="{FF2B5EF4-FFF2-40B4-BE49-F238E27FC236}">
+                <a16:creationId xmlns:a16="http://schemas.microsoft.com/office/drawing/2014/main" id="{DE22ECB7-C120-0F9B-2934-4B425F713364}"/>
+              </a:ext>
+            </a:extLst>
+          </p:cNvPr>
+          <p:cNvPicPr>
+            <a:picLocks noChangeAspect="1"/>
+          </p:cNvPicPr>
+          <p:nvPr/>
+        </p:nvPicPr>
+        <p:blipFill>
+          <a:blip r:embed="rId3"/>
+          <a:stretch>
+            <a:fillRect/>
+          </a:stretch>
+        </p:blipFill>
+        <p:spPr>
+          <a:xfrm>
+            <a:off x="845820" y="55634"/>
+            <a:ext cx="10664190" cy="6746732"/>
+          </a:xfrm>
+          <a:prstGeom prst="rect">
+            <a:avLst/>
+          </a:prstGeom>
+        </p:spPr>
+      </p:pic>
+    </p:spTree>
+    <p:extLst>
+      <p:ext uri="{BB962C8B-B14F-4D97-AF65-F5344CB8AC3E}">
+        <p14:creationId xmlns:p14="http://schemas.microsoft.com/office/powerpoint/2010/main" val="2217054714"/>
+      </p:ext>
+    </p:extLst>
+  </p:cSld>
+  <p:clrMapOvr>
+    <a:masterClrMapping/>
+  </p:clrMapOvr>
+</p:sld>
+</file>
+
+<file path=ppt/slides/slide7.xml><?xml version="1.0" encoding="utf-8"?>
+<p:sld xmlns:a="http://schemas.openxmlformats.org/drawingml/2006/main" xmlns:r="http://schemas.openxmlformats.org/officeDocument/2006/relationships" xmlns:p="http://schemas.openxmlformats.org/presentationml/2006/main">
+  <p:cSld>
+    <p:spTree>
+      <p:nvGrpSpPr>
+        <p:cNvPr id="1" name="">
+          <a:extLst>
+            <a:ext uri="{FF2B5EF4-FFF2-40B4-BE49-F238E27FC236}">
+              <a16:creationId xmlns:a16="http://schemas.microsoft.com/office/drawing/2014/main" id="{FCBC8EC4-7D06-D0A8-F333-9D6AA72A8AAE}"/>
+            </a:ext>
+          </a:extLst>
+        </p:cNvPr>
+        <p:cNvGrpSpPr/>
+        <p:nvPr/>
+      </p:nvGrpSpPr>
+      <p:grpSpPr>
+        <a:xfrm>
+          <a:off x="0" y="0"/>
+          <a:ext cx="0" cy="0"/>
+          <a:chOff x="0" y="0"/>
+          <a:chExt cx="0" cy="0"/>
+        </a:xfrm>
+      </p:grpSpPr>
+      <p:sp>
+        <p:nvSpPr>
+          <p:cNvPr id="2" name="Title 1">
+            <a:extLst>
+              <a:ext uri="{FF2B5EF4-FFF2-40B4-BE49-F238E27FC236}">
+                <a16:creationId xmlns:a16="http://schemas.microsoft.com/office/drawing/2014/main" id="{7B4F989E-1742-9F9C-D708-B1D26D3B1C58}"/>
+              </a:ext>
+            </a:extLst>
+          </p:cNvPr>
+          <p:cNvSpPr>
+            <a:spLocks noGrp="1"/>
+          </p:cNvSpPr>
+          <p:nvPr>
+            <p:ph type="title"/>
+          </p:nvPr>
+        </p:nvSpPr>
+        <p:spPr>
+          <a:xfrm>
+            <a:off x="182880" y="219456"/>
+            <a:ext cx="10835640" cy="791926"/>
+          </a:xfrm>
+        </p:spPr>
+        <p:txBody>
+          <a:bodyPr>
+            <a:normAutofit fontScale="90000"/>
+          </a:bodyPr>
+          <a:lstStyle/>
+          <a:p>
+            <a:br>
+              <a:rPr lang="en-US" sz="3200" dirty="0"/>
+            </a:br>
+            <a:r>
+              <a:rPr lang="en-US" sz="3200" dirty="0"/>
+              <a:t>						Violin Electricity</a:t>
+            </a:r>
+          </a:p>
+        </p:txBody>
+      </p:sp>
+      <p:pic>
+        <p:nvPicPr>
+          <p:cNvPr id="5" name="Picture 4">
+            <a:extLst>
+              <a:ext uri="{FF2B5EF4-FFF2-40B4-BE49-F238E27FC236}">
+                <a16:creationId xmlns:a16="http://schemas.microsoft.com/office/drawing/2014/main" id="{7ABC784D-037D-1598-8764-EC54F0C9E1FE}"/>
+              </a:ext>
+            </a:extLst>
+          </p:cNvPr>
+          <p:cNvPicPr>
+            <a:picLocks noChangeAspect="1"/>
+          </p:cNvPicPr>
+          <p:nvPr/>
+        </p:nvPicPr>
+        <p:blipFill>
+          <a:blip r:embed="rId3"/>
+          <a:stretch>
+            <a:fillRect/>
+          </a:stretch>
+        </p:blipFill>
+        <p:spPr>
+          <a:xfrm>
+            <a:off x="833719" y="99801"/>
+            <a:ext cx="10555940" cy="6678247"/>
+          </a:xfrm>
+          <a:prstGeom prst="rect">
+            <a:avLst/>
+          </a:prstGeom>
+        </p:spPr>
+      </p:pic>
+    </p:spTree>
+    <p:extLst>
+      <p:ext uri="{BB962C8B-B14F-4D97-AF65-F5344CB8AC3E}">
+        <p14:creationId xmlns:p14="http://schemas.microsoft.com/office/powerpoint/2010/main" val="1425292552"/>
+      </p:ext>
+    </p:extLst>
+  </p:cSld>
+  <p:clrMapOvr>
+    <a:masterClrMapping/>
+  </p:clrMapOvr>
+</p:sld>
+</file>
+
+<file path=ppt/slides/slide8.xml><?xml version="1.0" encoding="utf-8"?>
+<p:sld xmlns:a="http://schemas.openxmlformats.org/drawingml/2006/main" xmlns:r="http://schemas.openxmlformats.org/officeDocument/2006/relationships" xmlns:p="http://schemas.openxmlformats.org/presentationml/2006/main">
+  <p:cSld>
+    <p:spTree>
+      <p:nvGrpSpPr>
+        <p:cNvPr id="1" name="">
+          <a:extLst>
+            <a:ext uri="{FF2B5EF4-FFF2-40B4-BE49-F238E27FC236}">
+              <a16:creationId xmlns:a16="http://schemas.microsoft.com/office/drawing/2014/main" id="{7909BF10-2F27-4FD8-C254-10DA5D925472}"/>
+            </a:ext>
+          </a:extLst>
+        </p:cNvPr>
+        <p:cNvGrpSpPr/>
+        <p:nvPr/>
+      </p:nvGrpSpPr>
+      <p:grpSpPr>
+        <a:xfrm>
+          <a:off x="0" y="0"/>
+          <a:ext cx="0" cy="0"/>
+          <a:chOff x="0" y="0"/>
+          <a:chExt cx="0" cy="0"/>
+        </a:xfrm>
+      </p:grpSpPr>
+      <p:sp>
+        <p:nvSpPr>
+          <p:cNvPr id="2" name="Title 1">
+            <a:extLst>
+              <a:ext uri="{FF2B5EF4-FFF2-40B4-BE49-F238E27FC236}">
+                <a16:creationId xmlns:a16="http://schemas.microsoft.com/office/drawing/2014/main" id="{37162085-1026-5984-442D-00085A0FE72D}"/>
+              </a:ext>
+            </a:extLst>
+          </p:cNvPr>
+          <p:cNvSpPr>
+            <a:spLocks noGrp="1"/>
+          </p:cNvSpPr>
+          <p:nvPr>
+            <p:ph type="title"/>
+          </p:nvPr>
+        </p:nvSpPr>
+        <p:spPr>
+          <a:xfrm>
+            <a:off x="182880" y="219456"/>
+            <a:ext cx="10835640" cy="791926"/>
+          </a:xfrm>
+        </p:spPr>
+        <p:txBody>
+          <a:bodyPr>
+            <a:normAutofit fontScale="90000"/>
+          </a:bodyPr>
+          <a:lstStyle/>
+          <a:p>
+            <a:br>
+              <a:rPr lang="en-US" sz="3200" dirty="0"/>
+            </a:br>
+            <a:r>
+              <a:rPr lang="en-US" sz="3200" dirty="0"/>
+              <a:t>	Scatter electricity full</a:t>
+            </a:r>
+          </a:p>
+        </p:txBody>
+      </p:sp>
+      <p:pic>
+        <p:nvPicPr>
+          <p:cNvPr id="7" name="Picture 6">
+            <a:extLst>
+              <a:ext uri="{FF2B5EF4-FFF2-40B4-BE49-F238E27FC236}">
+                <a16:creationId xmlns:a16="http://schemas.microsoft.com/office/drawing/2014/main" id="{C23258DC-18E1-D40E-BD45-F41FBD323AEE}"/>
+              </a:ext>
+            </a:extLst>
+          </p:cNvPr>
+          <p:cNvPicPr>
+            <a:picLocks noChangeAspect="1"/>
+          </p:cNvPicPr>
+          <p:nvPr/>
+        </p:nvPicPr>
+        <p:blipFill>
+          <a:blip r:embed="rId3"/>
+          <a:stretch>
+            <a:fillRect/>
+          </a:stretch>
+        </p:blipFill>
+        <p:spPr>
+          <a:xfrm>
+            <a:off x="887506" y="133830"/>
+            <a:ext cx="10421470" cy="6593174"/>
+          </a:xfrm>
+          <a:prstGeom prst="rect">
+            <a:avLst/>
+          </a:prstGeom>
+        </p:spPr>
+      </p:pic>
+    </p:spTree>
+    <p:extLst>
+      <p:ext uri="{BB962C8B-B14F-4D97-AF65-F5344CB8AC3E}">
+        <p14:creationId xmlns:p14="http://schemas.microsoft.com/office/powerpoint/2010/main" val="725740804"/>
+      </p:ext>
+    </p:extLst>
+  </p:cSld>
+  <p:clrMapOvr>
+    <a:masterClrMapping/>
+  </p:clrMapOvr>
+</p:sld>
+</file>
+
+<file path=ppt/slides/slide9.xml><?xml version="1.0" encoding="utf-8"?>
+<p:sld xmlns:a="http://schemas.openxmlformats.org/drawingml/2006/main" xmlns:r="http://schemas.openxmlformats.org/officeDocument/2006/relationships" xmlns:p="http://schemas.openxmlformats.org/presentationml/2006/main">
+  <p:cSld>
+    <p:spTree>
+      <p:nvGrpSpPr>
+        <p:cNvPr id="1" name="">
+          <a:extLst>
+            <a:ext uri="{FF2B5EF4-FFF2-40B4-BE49-F238E27FC236}">
+              <a16:creationId xmlns:a16="http://schemas.microsoft.com/office/drawing/2014/main" id="{A43E715E-BC29-C89C-C6DB-536868633012}"/>
+            </a:ext>
+          </a:extLst>
+        </p:cNvPr>
+        <p:cNvGrpSpPr/>
+        <p:nvPr/>
+      </p:nvGrpSpPr>
+      <p:grpSpPr>
+        <a:xfrm>
+          <a:off x="0" y="0"/>
+          <a:ext cx="0" cy="0"/>
+          <a:chOff x="0" y="0"/>
+          <a:chExt cx="0" cy="0"/>
+        </a:xfrm>
+      </p:grpSpPr>
+      <p:sp>
+        <p:nvSpPr>
+          <p:cNvPr id="2" name="Title 1">
+            <a:extLst>
+              <a:ext uri="{FF2B5EF4-FFF2-40B4-BE49-F238E27FC236}">
+                <a16:creationId xmlns:a16="http://schemas.microsoft.com/office/drawing/2014/main" id="{A242D50D-9C05-B945-E674-8E72A50FB96B}"/>
+              </a:ext>
+            </a:extLst>
+          </p:cNvPr>
+          <p:cNvSpPr>
+            <a:spLocks noGrp="1"/>
+          </p:cNvSpPr>
+          <p:nvPr>
+            <p:ph type="title"/>
+          </p:nvPr>
+        </p:nvSpPr>
+        <p:spPr>
+          <a:xfrm>
+            <a:off x="182880" y="219456"/>
+            <a:ext cx="10835640" cy="506685"/>
+          </a:xfrm>
+        </p:spPr>
+        <p:txBody>
+          <a:bodyPr>
+            <a:normAutofit/>
+          </a:bodyPr>
+          <a:lstStyle/>
+          <a:p>
+            <a:r>
+              <a:rPr lang="en-US" sz="2800" dirty="0"/>
+              <a:t>	Electricity use by floor area, zoomed</a:t>
+            </a:r>
+          </a:p>
+        </p:txBody>
+      </p:sp>
+      <p:pic>
+        <p:nvPicPr>
+          <p:cNvPr id="5" name="Picture 4">
+            <a:extLst>
+              <a:ext uri="{FF2B5EF4-FFF2-40B4-BE49-F238E27FC236}">
+                <a16:creationId xmlns:a16="http://schemas.microsoft.com/office/drawing/2014/main" id="{3FEC36D6-6A09-36DA-B6F9-005031681BD3}"/>
+              </a:ext>
+            </a:extLst>
+          </p:cNvPr>
+          <p:cNvPicPr>
+            <a:picLocks noChangeAspect="1"/>
+          </p:cNvPicPr>
+          <p:nvPr/>
+        </p:nvPicPr>
+        <p:blipFill>
+          <a:blip r:embed="rId3"/>
+          <a:stretch>
+            <a:fillRect/>
+          </a:stretch>
+        </p:blipFill>
+        <p:spPr>
+          <a:xfrm>
+            <a:off x="846417" y="116236"/>
+            <a:ext cx="10486298" cy="6634188"/>
+          </a:xfrm>
+          <a:prstGeom prst="rect">
+            <a:avLst/>
+          </a:prstGeom>
+        </p:spPr>
+      </p:pic>
+    </p:spTree>
+    <p:extLst>
+      <p:ext uri="{BB962C8B-B14F-4D97-AF65-F5344CB8AC3E}">
+        <p14:creationId xmlns:p14="http://schemas.microsoft.com/office/powerpoint/2010/main" val="2733923395"/>
       </p:ext>
     </p:extLst>
   </p:cSld>

</xml_diff>

<commit_message>
move pics to new folder
</commit_message>
<xml_diff>
--- a/project1/Proj1_Present_Energy_Ouspenskaia.pptx
+++ b/project1/Proj1_Present_Energy_Ouspenskaia.pptx
@@ -1566,6 +1566,68 @@
         <p:txBody>
           <a:bodyPr/>
           <a:lstStyle/>
+          <a:p>
+            <a:pPr marL="0" marR="0" lvl="0" indent="0" algn="l" defTabSz="914400" rtl="0" eaLnBrk="1" fontAlgn="auto" latinLnBrk="0" hangingPunct="1">
+              <a:lnSpc>
+                <a:spcPct val="100000"/>
+              </a:lnSpc>
+              <a:spcBef>
+                <a:spcPts val="0"/>
+              </a:spcBef>
+              <a:spcAft>
+                <a:spcPts val="0"/>
+              </a:spcAft>
+              <a:buClrTx/>
+              <a:buSzTx/>
+              <a:buFontTx/>
+              <a:buNone/>
+              <a:tabLst/>
+              <a:defRPr/>
+            </a:pPr>
+            <a:r>
+              <a:rPr lang="en-US" sz="2400" b="0" kern="1200" dirty="0">
+                <a:solidFill>
+                  <a:schemeClr val="tx1"/>
+                </a:solidFill>
+                <a:effectLst/>
+                <a:latin typeface="+mn-lt"/>
+                <a:ea typeface="+mn-ea"/>
+                <a:cs typeface="+mn-cs"/>
+              </a:rPr>
+              <a:t>Top 9 categories:  all have &gt; 50 instances.  The rest grouped into “other”.</a:t>
+            </a:r>
+          </a:p>
+          <a:p>
+            <a:pPr marL="0" marR="0" lvl="0" indent="0" algn="l" defTabSz="914400" rtl="0" eaLnBrk="1" fontAlgn="auto" latinLnBrk="0" hangingPunct="1">
+              <a:lnSpc>
+                <a:spcPct val="100000"/>
+              </a:lnSpc>
+              <a:spcBef>
+                <a:spcPts val="0"/>
+              </a:spcBef>
+              <a:spcAft>
+                <a:spcPts val="0"/>
+              </a:spcAft>
+              <a:buClrTx/>
+              <a:buSzTx/>
+              <a:buFontTx/>
+              <a:buNone/>
+              <a:tabLst/>
+              <a:defRPr/>
+            </a:pPr>
+            <a:r>
+              <a:rPr lang="en-US" sz="2400" b="0" kern="1200" dirty="0">
+                <a:solidFill>
+                  <a:schemeClr val="tx1"/>
+                </a:solidFill>
+                <a:effectLst/>
+                <a:latin typeface="+mn-lt"/>
+                <a:ea typeface="+mn-ea"/>
+                <a:cs typeface="+mn-cs"/>
+              </a:rPr>
+              <a:t>58 categories total</a:t>
+            </a:r>
+          </a:p>
           <a:p>
             <a:pPr marL="0" marR="0" lvl="0" indent="0" algn="l" defTabSz="914400" rtl="0" eaLnBrk="1" fontAlgn="auto" latinLnBrk="0" hangingPunct="1">
               <a:lnSpc>
@@ -11337,7 +11399,7 @@
         </p:nvSpPr>
         <p:spPr>
           <a:xfrm>
-            <a:off x="451821" y="451821"/>
+            <a:off x="335280" y="1140444"/>
             <a:ext cx="11521440" cy="1731981"/>
           </a:xfrm>
         </p:spPr>
@@ -11347,19 +11409,21 @@
           </a:bodyPr>
           <a:lstStyle/>
           <a:p>
-            <a:r>
-              <a:rPr lang="en-US" sz="4400" dirty="0">
+            <a:pPr>
+              <a:lnSpc>
+                <a:spcPct val="150000"/>
+              </a:lnSpc>
+            </a:pPr>
+            <a:r>
+              <a:rPr lang="en-US" sz="3600" dirty="0">
                 <a:solidFill>
-                  <a:schemeClr val="tx1"/>
+                  <a:schemeClr val="tx1">
+                    <a:lumMod val="85000"/>
+                  </a:schemeClr>
                 </a:solidFill>
               </a:rPr>
-              <a:t>Which types of buildings in Montgomery County are Energy – Efficient?</a:t>
-            </a:r>
-            <a:endParaRPr lang="en-US" dirty="0">
-              <a:solidFill>
-                <a:schemeClr val="tx1"/>
-              </a:solidFill>
-            </a:endParaRPr>
+              <a:t>Which types of buildings in Montgomery County are more Energy – Efficient?</a:t>
+            </a:r>
           </a:p>
         </p:txBody>
       </p:sp>
@@ -11381,8 +11445,8 @@
         </p:nvSpPr>
         <p:spPr>
           <a:xfrm>
-            <a:off x="2420471" y="2635625"/>
-            <a:ext cx="7691717" cy="3227294"/>
+            <a:off x="2383283" y="3985576"/>
+            <a:ext cx="7425433" cy="2296226"/>
           </a:xfrm>
         </p:spPr>
         <p:txBody>
@@ -11392,9 +11456,11 @@
           <a:lstStyle/>
           <a:p>
             <a:r>
-              <a:rPr lang="en-US" sz="3200" dirty="0">
+              <a:rPr lang="en-US" sz="2800" dirty="0">
                 <a:solidFill>
-                  <a:schemeClr val="tx1"/>
+                  <a:schemeClr val="tx1">
+                    <a:lumMod val="85000"/>
+                  </a:schemeClr>
                 </a:solidFill>
               </a:rPr>
               <a:t>Alissa Ouspenskaia</a:t>
@@ -11402,9 +11468,11 @@
           </a:p>
           <a:p>
             <a:r>
-              <a:rPr lang="en-US" sz="3200" dirty="0">
+              <a:rPr lang="en-US" sz="2800" dirty="0">
                 <a:solidFill>
-                  <a:schemeClr val="tx1"/>
+                  <a:schemeClr val="tx1">
+                    <a:lumMod val="85000"/>
+                  </a:schemeClr>
                 </a:solidFill>
               </a:rPr>
               <a:t>DATA 110 </a:t>
@@ -11412,9 +11480,11 @@
           </a:p>
           <a:p>
             <a:r>
-              <a:rPr lang="en-US" sz="3200" dirty="0">
+              <a:rPr lang="en-US" sz="2800" dirty="0">
                 <a:solidFill>
-                  <a:schemeClr val="tx1"/>
+                  <a:schemeClr val="tx1">
+                    <a:lumMod val="85000"/>
+                  </a:schemeClr>
                 </a:solidFill>
               </a:rPr>
               <a:t>Montgomery College, Fall 2026</a:t>
@@ -11584,7 +11654,7 @@
         </p:nvSpPr>
         <p:spPr>
           <a:xfrm>
-            <a:off x="182880" y="219456"/>
+            <a:off x="295769" y="1325848"/>
             <a:ext cx="10835640" cy="791926"/>
           </a:xfrm>
         </p:spPr>
@@ -11595,8 +11665,14 @@
           <a:lstStyle/>
           <a:p>
             <a:r>
-              <a:rPr lang="en-US" sz="3200" dirty="0"/>
-              <a:t>Surprising findings: </a:t>
+              <a:rPr lang="en-US" sz="3200" dirty="0">
+                <a:solidFill>
+                  <a:schemeClr val="tx1">
+                    <a:lumMod val="85000"/>
+                  </a:schemeClr>
+                </a:solidFill>
+              </a:rPr>
+              <a:t>Surprising findings</a:t>
             </a:r>
           </a:p>
         </p:txBody>
@@ -11615,7 +11691,7 @@
         </p:nvSpPr>
         <p:spPr>
           <a:xfrm>
-            <a:off x="1816677" y="1952452"/>
+            <a:off x="1896687" y="2731385"/>
             <a:ext cx="10295313" cy="2800767"/>
           </a:xfrm>
           <a:prstGeom prst="rect">
@@ -11630,25 +11706,55 @@
           <a:lstStyle/>
           <a:p>
             <a:r>
-              <a:rPr lang="en-US" sz="2800" dirty="0"/>
+              <a:rPr lang="en-US" sz="2800" dirty="0">
+                <a:solidFill>
+                  <a:schemeClr val="tx1">
+                    <a:lumMod val="85000"/>
+                  </a:schemeClr>
+                </a:solidFill>
+              </a:rPr>
               <a:t>Building age vs. Total GHG emissions</a:t>
             </a:r>
           </a:p>
           <a:p>
-            <a:endParaRPr lang="en-US" sz="2800" dirty="0"/>
-          </a:p>
-          <a:p>
-            <a:r>
-              <a:rPr lang="en-US" sz="2800" dirty="0"/>
+            <a:endParaRPr lang="en-US" sz="2800" dirty="0">
+              <a:solidFill>
+                <a:schemeClr val="tx1">
+                  <a:lumMod val="85000"/>
+                </a:schemeClr>
+              </a:solidFill>
+            </a:endParaRPr>
+          </a:p>
+          <a:p>
+            <a:r>
+              <a:rPr lang="en-US" sz="2800" dirty="0">
+                <a:solidFill>
+                  <a:schemeClr val="tx1">
+                    <a:lumMod val="85000"/>
+                  </a:schemeClr>
+                </a:solidFill>
+              </a:rPr>
               <a:t>Building age vs. ENERGY STAR score</a:t>
             </a:r>
           </a:p>
           <a:p>
-            <a:endParaRPr lang="en-US" sz="2800" dirty="0"/>
-          </a:p>
-          <a:p>
-            <a:r>
-              <a:rPr lang="en-US" sz="2800" dirty="0"/>
+            <a:endParaRPr lang="en-US" sz="2800" dirty="0">
+              <a:solidFill>
+                <a:schemeClr val="tx1">
+                  <a:lumMod val="85000"/>
+                </a:schemeClr>
+              </a:solidFill>
+            </a:endParaRPr>
+          </a:p>
+          <a:p>
+            <a:r>
+              <a:rPr lang="en-US" sz="2800" dirty="0">
+                <a:solidFill>
+                  <a:schemeClr val="tx1">
+                    <a:lumMod val="85000"/>
+                  </a:schemeClr>
+                </a:solidFill>
+              </a:rPr>
               <a:t>ENERGY STAR score vs. Total GHG emissions</a:t>
             </a:r>
           </a:p>
@@ -11826,7 +11932,13 @@
           <a:lstStyle/>
           <a:p>
             <a:r>
-              <a:rPr lang="en-US" sz="3200" dirty="0"/>
+              <a:rPr lang="en-US" sz="3200" dirty="0">
+                <a:solidFill>
+                  <a:schemeClr val="tx1">
+                    <a:lumMod val="85000"/>
+                  </a:schemeClr>
+                </a:solidFill>
+              </a:rPr>
               <a:t>Further study</a:t>
             </a:r>
           </a:p>
@@ -11861,19 +11973,43 @@
           <a:lstStyle/>
           <a:p>
             <a:r>
-              <a:rPr lang="en-US" sz="2800" dirty="0"/>
+              <a:rPr lang="en-US" sz="2800" dirty="0">
+                <a:solidFill>
+                  <a:schemeClr val="tx1">
+                    <a:lumMod val="85000"/>
+                  </a:schemeClr>
+                </a:solidFill>
+              </a:rPr>
               <a:t>Explore more variables that may contribute to ENERGY STAR scores and try to find some stronger relationships.</a:t>
             </a:r>
           </a:p>
           <a:p>
-            <a:endParaRPr lang="en-US" sz="2800" dirty="0"/>
-          </a:p>
-          <a:p>
-            <a:r>
-              <a:rPr lang="en-US" sz="2800" dirty="0"/>
+            <a:endParaRPr lang="en-US" sz="2800" dirty="0">
+              <a:solidFill>
+                <a:schemeClr val="tx1">
+                  <a:lumMod val="85000"/>
+                </a:schemeClr>
+              </a:solidFill>
+            </a:endParaRPr>
+          </a:p>
+          <a:p>
+            <a:r>
+              <a:rPr lang="en-US" sz="2800" dirty="0">
+                <a:solidFill>
+                  <a:schemeClr val="tx1">
+                    <a:lumMod val="85000"/>
+                  </a:schemeClr>
+                </a:solidFill>
+              </a:rPr>
               <a:t>Compare 2022 data with this 2023 data. </a:t>
             </a:r>
-            <a:endParaRPr lang="en-US" dirty="0"/>
+            <a:endParaRPr lang="en-US" dirty="0">
+              <a:solidFill>
+                <a:schemeClr val="tx1">
+                  <a:lumMod val="85000"/>
+                </a:schemeClr>
+              </a:solidFill>
+            </a:endParaRPr>
           </a:p>
           <a:p>
             <a:endParaRPr lang="en-US" dirty="0"/>
@@ -11929,13 +12065,24 @@
             <p:ph type="title"/>
           </p:nvPr>
         </p:nvSpPr>
-        <p:spPr/>
+        <p:spPr>
+          <a:xfrm>
+            <a:off x="239325" y="738746"/>
+            <a:ext cx="10835640" cy="762677"/>
+          </a:xfrm>
+        </p:spPr>
         <p:txBody>
           <a:bodyPr/>
           <a:lstStyle/>
           <a:p>
             <a:r>
-              <a:rPr lang="en-US" dirty="0"/>
+              <a:rPr lang="en-US" dirty="0">
+                <a:solidFill>
+                  <a:schemeClr val="tx1">
+                    <a:lumMod val="85000"/>
+                  </a:schemeClr>
+                </a:solidFill>
+              </a:rPr>
               <a:t>Sources and Notes</a:t>
             </a:r>
           </a:p>
@@ -11970,38 +12117,70 @@
           <a:lstStyle/>
           <a:p>
             <a:r>
-              <a:rPr lang="en-US" dirty="0"/>
+              <a:rPr lang="en-US" dirty="0">
+                <a:solidFill>
+                  <a:schemeClr val="tx1">
+                    <a:lumMod val="85000"/>
+                  </a:schemeClr>
+                </a:solidFill>
+              </a:rPr>
               <a:t>2023 Energy Benchmarking All Sites</a:t>
             </a:r>
           </a:p>
           <a:p>
             <a:r>
-              <a:rPr lang="en-US" dirty="0"/>
+              <a:rPr lang="en-US" dirty="0">
+                <a:solidFill>
+                  <a:schemeClr val="tx1">
+                    <a:lumMod val="85000"/>
+                  </a:schemeClr>
+                </a:solidFill>
+              </a:rPr>
               <a:t>The Energy Benchmarking Law requires the County to make annually reported energy benchmarking information readily available to the public. This dataset reflects data received by the publish date and does not include individually attributable benchmarking data for buildings in Group 5, as CY 2023 was the first year that these buildings were required to report to DEP.</a:t>
             </a:r>
           </a:p>
           <a:p>
             <a:r>
-              <a:rPr lang="en-US" dirty="0"/>
+              <a:rPr lang="en-US" dirty="0">
+                <a:solidFill>
+                  <a:schemeClr val="tx1">
+                    <a:lumMod val="85000"/>
+                  </a:schemeClr>
+                </a:solidFill>
+              </a:rPr>
               <a:t>September 23, 2025</a:t>
             </a:r>
           </a:p>
           <a:p>
             <a:r>
-              <a:rPr lang="en-US" dirty="0"/>
+              <a:rPr lang="en-US" dirty="0">
+                <a:solidFill>
+                  <a:schemeClr val="tx1">
+                    <a:lumMod val="85000"/>
+                  </a:schemeClr>
+                </a:solidFill>
+              </a:rPr>
               <a:t>Dataset Owner: Kathy Luh</a:t>
             </a:r>
           </a:p>
           <a:p>
             <a:r>
-              <a:rPr lang="en-US" dirty="0"/>
+              <a:rPr lang="en-US" dirty="0">
+                <a:solidFill>
+                  <a:schemeClr val="tx1">
+                    <a:lumMod val="85000"/>
+                  </a:schemeClr>
+                </a:solidFill>
+              </a:rPr>
               <a:t>27 columns 1846 rows</a:t>
             </a:r>
           </a:p>
           <a:p>
             <a:endParaRPr lang="en-US" sz="1800" b="0" i="0" dirty="0">
               <a:solidFill>
-                <a:srgbClr val="9454C3"/>
+                <a:schemeClr val="tx1">
+                  <a:lumMod val="85000"/>
+                </a:schemeClr>
               </a:solidFill>
               <a:effectLst/>
               <a:latin typeface="+mn-lt"/>
@@ -12016,6 +12195,11 @@
           </a:p>
           <a:p>
             <a:endParaRPr lang="en-US" dirty="0">
+              <a:solidFill>
+                <a:schemeClr val="tx1">
+                  <a:lumMod val="85000"/>
+                </a:schemeClr>
+              </a:solidFill>
               <a:hlinkClick r:id="rId3">
                 <a:extLst>
                   <a:ext uri="{A12FA001-AC4F-418D-AE19-62706E023703}">
@@ -12028,6 +12212,11 @@
           <a:p>
             <a:r>
               <a:rPr lang="en-US" dirty="0">
+                <a:solidFill>
+                  <a:schemeClr val="tx1">
+                    <a:lumMod val="85000"/>
+                  </a:schemeClr>
+                </a:solidFill>
                 <a:hlinkClick r:id="rId3">
                   <a:extLst>
                     <a:ext uri="{A12FA001-AC4F-418D-AE19-62706E023703}">
@@ -12038,14 +12227,31 @@
               </a:rPr>
               <a:t>https://data.montgomerycountymd.gov/Environment/2023-Energy-Benchmarking-All-Sites/ensr-8pr2/about_data</a:t>
             </a:r>
-            <a:endParaRPr lang="en-US" dirty="0"/>
-          </a:p>
-          <a:p>
-            <a:endParaRPr lang="en-US" dirty="0"/>
+            <a:endParaRPr lang="en-US" dirty="0">
+              <a:solidFill>
+                <a:schemeClr val="tx1">
+                  <a:lumMod val="85000"/>
+                </a:schemeClr>
+              </a:solidFill>
+            </a:endParaRPr>
+          </a:p>
+          <a:p>
+            <a:endParaRPr lang="en-US" dirty="0">
+              <a:solidFill>
+                <a:schemeClr val="tx1">
+                  <a:lumMod val="85000"/>
+                </a:schemeClr>
+              </a:solidFill>
+            </a:endParaRPr>
           </a:p>
           <a:p>
             <a:r>
               <a:rPr lang="en-US" dirty="0">
+                <a:solidFill>
+                  <a:schemeClr val="tx1">
+                    <a:lumMod val="85000"/>
+                  </a:schemeClr>
+                </a:solidFill>
                 <a:hlinkClick r:id="rId4">
                   <a:extLst>
                     <a:ext uri="{A12FA001-AC4F-418D-AE19-62706E023703}">
@@ -12056,20 +12262,42 @@
               </a:rPr>
               <a:t>https://www.energystar.gov/buildings/benchmark</a:t>
             </a:r>
-            <a:endParaRPr lang="en-US" dirty="0"/>
+            <a:endParaRPr lang="en-US" dirty="0">
+              <a:solidFill>
+                <a:schemeClr val="tx1">
+                  <a:lumMod val="85000"/>
+                </a:schemeClr>
+              </a:solidFill>
+            </a:endParaRPr>
           </a:p>
           <a:p>
             <a:endParaRPr lang="en-US" sz="1800" b="0" i="0" dirty="0">
+              <a:solidFill>
+                <a:schemeClr val="tx1">
+                  <a:lumMod val="85000"/>
+                </a:schemeClr>
+              </a:solidFill>
               <a:effectLst/>
               <a:latin typeface="+mn-lt"/>
             </a:endParaRPr>
           </a:p>
           <a:p>
             <a:r>
-              <a:rPr lang="en-US" u="sng" dirty="0"/>
+              <a:rPr lang="en-US" u="sng" dirty="0">
+                <a:solidFill>
+                  <a:schemeClr val="tx1">
+                    <a:lumMod val="85000"/>
+                  </a:schemeClr>
+                </a:solidFill>
+              </a:rPr>
               <a:t>https://www.energystar.gov/buildings/about-us</a:t>
             </a:r>
             <a:endParaRPr lang="en-US" sz="1800" b="0" i="0" u="sng" dirty="0">
+              <a:solidFill>
+                <a:schemeClr val="tx1">
+                  <a:lumMod val="85000"/>
+                </a:schemeClr>
+              </a:solidFill>
               <a:effectLst/>
               <a:latin typeface="+mn-lt"/>
             </a:endParaRPr>
@@ -12156,7 +12384,13 @@
           <a:lstStyle/>
           <a:p>
             <a:r>
-              <a:rPr lang="en-US" sz="3200" dirty="0"/>
+              <a:rPr lang="en-US" sz="3200" dirty="0">
+                <a:solidFill>
+                  <a:schemeClr val="tx1">
+                    <a:lumMod val="85000"/>
+                  </a:schemeClr>
+                </a:solidFill>
+              </a:rPr>
               <a:t>Notes</a:t>
             </a:r>
           </a:p>
@@ -12177,7 +12411,7 @@
         <p:spPr>
           <a:xfrm>
             <a:off x="1159626" y="1198072"/>
-            <a:ext cx="10295313" cy="3693319"/>
+            <a:ext cx="10295313" cy="5539978"/>
           </a:xfrm>
           <a:prstGeom prst="rect">
             <a:avLst/>
@@ -12191,41 +12425,227 @@
           <a:lstStyle/>
           <a:p>
             <a:r>
-              <a:rPr lang="en-US" sz="2400" dirty="0"/>
+              <a:rPr lang="en-US" sz="2400" dirty="0">
+                <a:solidFill>
+                  <a:schemeClr val="tx1">
+                    <a:lumMod val="85000"/>
+                  </a:schemeClr>
+                </a:solidFill>
+              </a:rPr>
               <a:t>Btu:  the British thermal unit (Btu) is a unit of measure of heat.  </a:t>
             </a:r>
           </a:p>
           <a:p>
             <a:r>
-              <a:rPr lang="en-US" sz="2400" dirty="0"/>
+              <a:rPr lang="en-US" sz="2400" dirty="0">
+                <a:solidFill>
+                  <a:schemeClr val="tx1">
+                    <a:lumMod val="85000"/>
+                  </a:schemeClr>
+                </a:solidFill>
+              </a:rPr>
               <a:t>It’s the amount of heat required to raise the temperature of one </a:t>
             </a:r>
           </a:p>
           <a:p>
             <a:r>
-              <a:rPr lang="en-US" sz="2400" dirty="0"/>
+              <a:rPr lang="en-US" sz="2400" dirty="0">
+                <a:solidFill>
+                  <a:schemeClr val="tx1">
+                    <a:lumMod val="85000"/>
+                  </a:schemeClr>
+                </a:solidFill>
+              </a:rPr>
               <a:t>pound of water by one degree Fahrenheit.</a:t>
             </a:r>
           </a:p>
           <a:p>
             <a:r>
-              <a:rPr lang="en-US" sz="2400" dirty="0"/>
+              <a:rPr lang="en-US" sz="2400" dirty="0">
+                <a:solidFill>
+                  <a:schemeClr val="tx1">
+                    <a:lumMod val="85000"/>
+                  </a:schemeClr>
+                </a:solidFill>
+              </a:rPr>
               <a:t>One Btu equals about 1,055 joules. </a:t>
             </a:r>
           </a:p>
           <a:p>
-            <a:endParaRPr lang="en-US" sz="2400" dirty="0"/>
-          </a:p>
-          <a:p>
-            <a:endParaRPr lang="en-US" sz="2400" dirty="0"/>
+            <a:endParaRPr lang="en-US" sz="2400" dirty="0">
+              <a:solidFill>
+                <a:schemeClr val="tx1">
+                  <a:lumMod val="85000"/>
+                </a:schemeClr>
+              </a:solidFill>
+            </a:endParaRPr>
           </a:p>
           <a:p>
             <a:pPr lvl="0">
               <a:defRPr/>
             </a:pPr>
             <a:r>
-              <a:rPr lang="en-US" sz="2400" dirty="0"/>
+              <a:rPr lang="en-US" sz="2400" dirty="0">
+                <a:solidFill>
+                  <a:schemeClr val="tx1">
+                    <a:lumMod val="85000"/>
+                  </a:schemeClr>
+                </a:solidFill>
+              </a:rPr>
               <a:t>Energy Star: 1–100 score, which rates energy performance in comparison to similar buildings across the country</a:t>
+            </a:r>
+          </a:p>
+          <a:p>
+            <a:pPr lvl="0">
+              <a:defRPr/>
+            </a:pPr>
+            <a:endParaRPr lang="en-US" sz="2400" dirty="0">
+              <a:solidFill>
+                <a:schemeClr val="tx1">
+                  <a:lumMod val="85000"/>
+                </a:schemeClr>
+              </a:solidFill>
+            </a:endParaRPr>
+          </a:p>
+          <a:p>
+            <a:pPr>
+              <a:defRPr/>
+            </a:pPr>
+            <a:r>
+              <a:rPr lang="en-US" sz="2400" dirty="0">
+                <a:solidFill>
+                  <a:schemeClr val="tx1">
+                    <a:lumMod val="85000"/>
+                  </a:schemeClr>
+                </a:solidFill>
+              </a:rPr>
+              <a:t>Dataset:  </a:t>
+            </a:r>
+            <a:r>
+              <a:rPr lang="en-US" sz="2400" dirty="0">
+                <a:solidFill>
+                  <a:schemeClr val="tx1">
+                    <a:lumMod val="85000"/>
+                  </a:schemeClr>
+                </a:solidFill>
+                <a:hlinkClick r:id="rId3">
+                  <a:extLst>
+                    <a:ext uri="{A12FA001-AC4F-418D-AE19-62706E023703}">
+                      <ahyp:hlinkClr xmlns:ahyp="http://schemas.microsoft.com/office/drawing/2018/hyperlinkcolor" val="tx"/>
+                    </a:ext>
+                  </a:extLst>
+                </a:hlinkClick>
+              </a:rPr>
+              <a:t>https://raw.github.com/Alissa-Ouspen/data110_alissa/main/datasets/energy_2023_clean.csv</a:t>
+            </a:r>
+            <a:endParaRPr lang="en-US" sz="2400" dirty="0">
+              <a:solidFill>
+                <a:schemeClr val="tx1">
+                  <a:lumMod val="85000"/>
+                </a:schemeClr>
+              </a:solidFill>
+            </a:endParaRPr>
+          </a:p>
+          <a:p>
+            <a:pPr lvl="0">
+              <a:defRPr/>
+            </a:pPr>
+            <a:endParaRPr lang="en-US" sz="2400" dirty="0">
+              <a:solidFill>
+                <a:schemeClr val="tx1">
+                  <a:lumMod val="85000"/>
+                </a:schemeClr>
+              </a:solidFill>
+            </a:endParaRPr>
+          </a:p>
+          <a:p>
+            <a:pPr lvl="0">
+              <a:defRPr/>
+            </a:pPr>
+            <a:r>
+              <a:rPr lang="en-US" sz="2400" dirty="0">
+                <a:solidFill>
+                  <a:schemeClr val="tx1">
+                    <a:lumMod val="85000"/>
+                  </a:schemeClr>
+                </a:solidFill>
+              </a:rPr>
+              <a:t>Project folder in GitHub</a:t>
+            </a:r>
+            <a:r>
+              <a:rPr lang="en-US" sz="2400">
+                <a:solidFill>
+                  <a:schemeClr val="tx1">
+                    <a:lumMod val="85000"/>
+                  </a:schemeClr>
+                </a:solidFill>
+              </a:rPr>
+              <a:t>:  </a:t>
+            </a:r>
+          </a:p>
+          <a:p>
+            <a:pPr lvl="0">
+              <a:defRPr/>
+            </a:pPr>
+            <a:r>
+              <a:rPr lang="en-US" sz="2400">
+                <a:solidFill>
+                  <a:schemeClr val="tx1">
+                    <a:lumMod val="85000"/>
+                  </a:schemeClr>
+                </a:solidFill>
+              </a:rPr>
+              <a:t>https</a:t>
+            </a:r>
+            <a:r>
+              <a:rPr lang="en-US" sz="2400" dirty="0">
+                <a:solidFill>
+                  <a:schemeClr val="tx1">
+                    <a:lumMod val="85000"/>
+                  </a:schemeClr>
+                </a:solidFill>
+              </a:rPr>
+              <a:t>://</a:t>
+            </a:r>
+            <a:r>
+              <a:rPr lang="en-US" sz="2400" dirty="0" err="1">
+                <a:solidFill>
+                  <a:schemeClr val="tx1">
+                    <a:lumMod val="85000"/>
+                  </a:schemeClr>
+                </a:solidFill>
+              </a:rPr>
+              <a:t>github.com</a:t>
+            </a:r>
+            <a:r>
+              <a:rPr lang="en-US" sz="2400" dirty="0">
+                <a:solidFill>
+                  <a:schemeClr val="tx1">
+                    <a:lumMod val="85000"/>
+                  </a:schemeClr>
+                </a:solidFill>
+              </a:rPr>
+              <a:t>/Alissa-</a:t>
+            </a:r>
+            <a:r>
+              <a:rPr lang="en-US" sz="2400" dirty="0" err="1">
+                <a:solidFill>
+                  <a:schemeClr val="tx1">
+                    <a:lumMod val="85000"/>
+                  </a:schemeClr>
+                </a:solidFill>
+              </a:rPr>
+              <a:t>Ouspen</a:t>
+            </a:r>
+            <a:r>
+              <a:rPr lang="en-US" sz="2400" dirty="0">
+                <a:solidFill>
+                  <a:schemeClr val="tx1">
+                    <a:lumMod val="85000"/>
+                  </a:schemeClr>
+                </a:solidFill>
+              </a:rPr>
+              <a:t>/data110_alissa/tree/main/project1</a:t>
             </a:r>
           </a:p>
           <a:p>
@@ -12295,7 +12715,13 @@
           <a:lstStyle/>
           <a:p>
             <a:r>
-              <a:rPr lang="en-US" sz="3200" dirty="0"/>
+              <a:rPr lang="en-US" sz="3200" dirty="0">
+                <a:solidFill>
+                  <a:schemeClr val="tx1">
+                    <a:lumMod val="85000"/>
+                  </a:schemeClr>
+                </a:solidFill>
+              </a:rPr>
               <a:t>Source Dataset:</a:t>
             </a:r>
           </a:p>
@@ -12315,8 +12741,8 @@
         </p:nvSpPr>
         <p:spPr>
           <a:xfrm>
-            <a:off x="1330932" y="2626129"/>
-            <a:ext cx="8127403" cy="2646878"/>
+            <a:off x="1478844" y="2626129"/>
+            <a:ext cx="9369778" cy="3200876"/>
           </a:xfrm>
           <a:prstGeom prst="rect">
             <a:avLst/>
@@ -12330,19 +12756,24 @@
           <a:lstStyle/>
           <a:p>
             <a:r>
-              <a:rPr lang="en-US" sz="2800" dirty="0"/>
+              <a:rPr lang="en-US" sz="2400" dirty="0">
+                <a:solidFill>
+                  <a:schemeClr val="tx1">
+                    <a:lumMod val="85000"/>
+                  </a:schemeClr>
+                </a:solidFill>
+              </a:rPr>
               <a:t>2023 Energy Benchmarking All Sites</a:t>
             </a:r>
           </a:p>
           <a:p>
-            <a:endParaRPr lang="en-US" sz="2800" dirty="0"/>
-          </a:p>
-          <a:p>
-            <a:endParaRPr lang="en-US" sz="2800" dirty="0"/>
-          </a:p>
-          <a:p>
-            <a:r>
-              <a:rPr lang="en-US" sz="2800" u="sng" dirty="0">
+            <a:r>
+              <a:rPr lang="en-US" sz="2400" u="sng" dirty="0">
+                <a:solidFill>
+                  <a:schemeClr val="tx1">
+                    <a:lumMod val="85000"/>
+                  </a:schemeClr>
+                </a:solidFill>
                 <a:hlinkClick r:id="rId2">
                   <a:extLst>
                     <a:ext uri="{A12FA001-AC4F-418D-AE19-62706E023703}">
@@ -12353,10 +12784,100 @@
               </a:rPr>
               <a:t>https://data.montgomerycountymd.gov</a:t>
             </a:r>
-            <a:endParaRPr lang="en-US" sz="2800" u="sng" dirty="0"/>
-          </a:p>
-          <a:p>
-            <a:endParaRPr lang="en-US" dirty="0"/>
+            <a:endParaRPr lang="en-US" sz="2400" u="sng" dirty="0">
+              <a:solidFill>
+                <a:schemeClr val="tx1">
+                  <a:lumMod val="85000"/>
+                </a:schemeClr>
+              </a:solidFill>
+            </a:endParaRPr>
+          </a:p>
+          <a:p>
+            <a:endParaRPr lang="en-US" sz="2400" u="sng" dirty="0">
+              <a:solidFill>
+                <a:schemeClr val="tx1">
+                  <a:lumMod val="85000"/>
+                </a:schemeClr>
+              </a:solidFill>
+            </a:endParaRPr>
+          </a:p>
+          <a:p>
+            <a:r>
+              <a:rPr lang="en-US" sz="2400" dirty="0">
+                <a:solidFill>
+                  <a:schemeClr val="tx1">
+                    <a:lumMod val="85000"/>
+                  </a:schemeClr>
+                </a:solidFill>
+                <a:hlinkClick r:id="rId3">
+                  <a:extLst>
+                    <a:ext uri="{A12FA001-AC4F-418D-AE19-62706E023703}">
+                      <ahyp:hlinkClr xmlns:ahyp="http://schemas.microsoft.com/office/drawing/2018/hyperlinkcolor" val="tx"/>
+                    </a:ext>
+                  </a:extLst>
+                </a:hlinkClick>
+              </a:rPr>
+              <a:t>https://raw.github.com/Alissa-</a:t>
+            </a:r>
+            <a:r>
+              <a:rPr lang="en-US" sz="2400" dirty="0" err="1">
+                <a:solidFill>
+                  <a:schemeClr val="tx1">
+                    <a:lumMod val="85000"/>
+                  </a:schemeClr>
+                </a:solidFill>
+                <a:hlinkClick r:id="rId3">
+                  <a:extLst>
+                    <a:ext uri="{A12FA001-AC4F-418D-AE19-62706E023703}">
+                      <ahyp:hlinkClr xmlns:ahyp="http://schemas.microsoft.com/office/drawing/2018/hyperlinkcolor" val="tx"/>
+                    </a:ext>
+                  </a:extLst>
+                </a:hlinkClick>
+              </a:rPr>
+              <a:t>Ouspen</a:t>
+            </a:r>
+            <a:r>
+              <a:rPr lang="en-US" sz="2400" dirty="0">
+                <a:solidFill>
+                  <a:schemeClr val="tx1">
+                    <a:lumMod val="85000"/>
+                  </a:schemeClr>
+                </a:solidFill>
+                <a:hlinkClick r:id="rId3">
+                  <a:extLst>
+                    <a:ext uri="{A12FA001-AC4F-418D-AE19-62706E023703}">
+                      <ahyp:hlinkClr xmlns:ahyp="http://schemas.microsoft.com/office/drawing/2018/hyperlinkcolor" val="tx"/>
+                    </a:ext>
+                  </a:extLst>
+                </a:hlinkClick>
+              </a:rPr>
+              <a:t>/data110_alissa/main/datasets/energy_2023_clean.csv</a:t>
+            </a:r>
+            <a:endParaRPr lang="en-US" sz="2400" dirty="0">
+              <a:solidFill>
+                <a:schemeClr val="tx1">
+                  <a:lumMod val="85000"/>
+                </a:schemeClr>
+              </a:solidFill>
+            </a:endParaRPr>
+          </a:p>
+          <a:p>
+            <a:endParaRPr lang="en-US" sz="2800" u="sng" dirty="0">
+              <a:solidFill>
+                <a:schemeClr val="tx1">
+                  <a:lumMod val="85000"/>
+                </a:schemeClr>
+              </a:solidFill>
+            </a:endParaRPr>
+          </a:p>
+          <a:p>
+            <a:endParaRPr lang="en-US" dirty="0">
+              <a:solidFill>
+                <a:schemeClr val="tx1">
+                  <a:lumMod val="85000"/>
+                </a:schemeClr>
+              </a:solidFill>
+            </a:endParaRPr>
           </a:p>
           <a:p>
             <a:endParaRPr lang="en-US" sz="1800" dirty="0"/>
@@ -12425,7 +12946,13 @@
           <a:lstStyle/>
           <a:p>
             <a:r>
-              <a:rPr lang="en-US" sz="4000" dirty="0"/>
+              <a:rPr lang="en-US" sz="4000" dirty="0">
+                <a:solidFill>
+                  <a:schemeClr val="tx1">
+                    <a:lumMod val="85000"/>
+                  </a:schemeClr>
+                </a:solidFill>
+              </a:rPr>
               <a:t>What is Benchmarking?</a:t>
             </a:r>
             <a:br>
@@ -12518,7 +13045,13 @@
           <a:lstStyle/>
           <a:p>
             <a:r>
-              <a:rPr lang="en-US" sz="3200" dirty="0"/>
+              <a:rPr lang="en-US" sz="3200" dirty="0">
+                <a:solidFill>
+                  <a:schemeClr val="tx1">
+                    <a:lumMod val="85000"/>
+                  </a:schemeClr>
+                </a:solidFill>
+              </a:rPr>
               <a:t>Exploratory Analysis </a:t>
             </a:r>
           </a:p>
@@ -12558,7 +13091,13 @@
               </a:lnSpc>
             </a:pPr>
             <a:r>
-              <a:rPr lang="en-US" sz="2400" dirty="0"/>
+              <a:rPr lang="en-US" sz="2400" dirty="0">
+                <a:solidFill>
+                  <a:schemeClr val="tx1">
+                    <a:lumMod val="85000"/>
+                  </a:schemeClr>
+                </a:solidFill>
+              </a:rPr>
               <a:t>1846 rows, 27 columns </a:t>
             </a:r>
           </a:p>
@@ -12569,7 +13108,13 @@
               </a:lnSpc>
             </a:pPr>
             <a:r>
-              <a:rPr lang="en-US" sz="2400" dirty="0"/>
+              <a:rPr lang="en-US" sz="2400" dirty="0">
+                <a:solidFill>
+                  <a:schemeClr val="tx1">
+                    <a:lumMod val="85000"/>
+                  </a:schemeClr>
+                </a:solidFill>
+              </a:rPr>
               <a:t>Numerical and Categorical data</a:t>
             </a:r>
           </a:p>
@@ -12580,7 +13125,13 @@
               </a:lnSpc>
             </a:pPr>
             <a:r>
-              <a:rPr lang="en-US" sz="2400" dirty="0"/>
+              <a:rPr lang="en-US" sz="2400" dirty="0">
+                <a:solidFill>
+                  <a:schemeClr val="tx1">
+                    <a:lumMod val="85000"/>
+                  </a:schemeClr>
+                </a:solidFill>
+              </a:rPr>
               <a:t>25 duplicate entries</a:t>
             </a:r>
           </a:p>
@@ -12591,7 +13142,13 @@
               </a:lnSpc>
             </a:pPr>
             <a:r>
-              <a:rPr lang="en-US" sz="2400" dirty="0"/>
+              <a:rPr lang="en-US" sz="2400" dirty="0">
+                <a:solidFill>
+                  <a:schemeClr val="tx1">
+                    <a:lumMod val="85000"/>
+                  </a:schemeClr>
+                </a:solidFill>
+              </a:rPr>
               <a:t>1821 remaining</a:t>
             </a:r>
           </a:p>
@@ -12602,7 +13159,13 @@
               </a:lnSpc>
             </a:pPr>
             <a:r>
-              <a:rPr lang="en-US" sz="2400" dirty="0"/>
+              <a:rPr lang="en-US" sz="2400" dirty="0">
+                <a:solidFill>
+                  <a:schemeClr val="tx1">
+                    <a:lumMod val="85000"/>
+                  </a:schemeClr>
+                </a:solidFill>
+              </a:rPr>
               <a:t>Missing ID numbers and addresses</a:t>
             </a:r>
           </a:p>
@@ -12613,7 +13176,13 @@
               </a:lnSpc>
             </a:pPr>
             <a:r>
-              <a:rPr lang="en-US" sz="2400" dirty="0"/>
+              <a:rPr lang="en-US" sz="2400" dirty="0">
+                <a:solidFill>
+                  <a:schemeClr val="tx1">
+                    <a:lumMod val="85000"/>
+                  </a:schemeClr>
+                </a:solidFill>
+              </a:rPr>
               <a:t>Electricity (kWh) had the most unique entries:  	1716</a:t>
             </a:r>
           </a:p>
@@ -12624,7 +13193,13 @@
               </a:lnSpc>
             </a:pPr>
             <a:r>
-              <a:rPr lang="en-US" sz="2400" dirty="0"/>
+              <a:rPr lang="en-US" sz="2400" dirty="0">
+                <a:solidFill>
+                  <a:schemeClr val="tx1">
+                    <a:lumMod val="85000"/>
+                  </a:schemeClr>
+                </a:solidFill>
+              </a:rPr>
               <a:t>Reported Property Gross Floor Area unique: 		1672</a:t>
             </a:r>
           </a:p>
@@ -12635,7 +13210,13 @@
               </a:lnSpc>
             </a:pPr>
             <a:r>
-              <a:rPr lang="en-US" sz="2400" dirty="0"/>
+              <a:rPr lang="en-US" sz="2400" dirty="0">
+                <a:solidFill>
+                  <a:schemeClr val="tx1">
+                    <a:lumMod val="85000"/>
+                  </a:schemeClr>
+                </a:solidFill>
+              </a:rPr>
               <a:t>Total GHG Emissions (Metric Tons CO2e) unique:  	1619</a:t>
             </a:r>
           </a:p>

</xml_diff>